<commit_message>
what is Computer vision and how it is used
</commit_message>
<xml_diff>
--- a/2023263 AI CA1.pptx
+++ b/2023263 AI CA1.pptx
@@ -14173,10 +14173,10 @@
         </p:nvGrpSpPr>
         <p:grpSpPr>
           <a:xfrm>
-            <a:off x="942975" y="14095412"/>
-            <a:ext cx="12887325" cy="1108075"/>
+            <a:off x="967496" y="19544178"/>
+            <a:ext cx="12887106" cy="1108011"/>
             <a:chOff x="943194" y="16253059"/>
-            <a:chExt cx="12887106" cy="1107996"/>
+            <a:chExt cx="12887106" cy="1107900"/>
           </a:xfrm>
         </p:grpSpPr>
         <p:sp>
@@ -14188,7 +14188,7 @@
           <p:spPr>
             <a:xfrm>
               <a:off x="943194" y="16253059"/>
-              <a:ext cx="12887106" cy="1107996"/>
+              <a:ext cx="12887100" cy="1107900"/>
             </a:xfrm>
             <a:prstGeom prst="rect">
               <a:avLst/>
@@ -14273,9 +14273,9 @@
         <p:grpSpPr>
           <a:xfrm>
             <a:off x="920750" y="4964112"/>
-            <a:ext cx="12885737" cy="1108075"/>
+            <a:ext cx="12885737" cy="1000571"/>
             <a:chOff x="967545" y="5020846"/>
-            <a:chExt cx="12885433" cy="1107996"/>
+            <a:chExt cx="12885433" cy="1000500"/>
           </a:xfrm>
         </p:grpSpPr>
         <p:sp>
@@ -14287,7 +14287,7 @@
           <p:spPr>
             <a:xfrm>
               <a:off x="967545" y="5020846"/>
-              <a:ext cx="12885433" cy="1107996"/>
+              <a:ext cx="12885300" cy="1000500"/>
             </a:xfrm>
             <a:prstGeom prst="rect">
               <a:avLst/>
@@ -14321,18 +14321,14 @@
                 <a:buNone/>
               </a:pPr>
               <a:r>
-                <a:rPr b="1" i="0" lang="en-US" sz="6600" u="none">
+                <a:rPr b="1" lang="en-US" sz="5900">
                   <a:solidFill>
                     <a:srgbClr val="006684"/>
                   </a:solidFill>
-                  <a:latin typeface="Arial"/>
-                  <a:ea typeface="Arial"/>
-                  <a:cs typeface="Arial"/>
-                  <a:sym typeface="Arial"/>
                 </a:rPr>
-                <a:t>Introduction</a:t>
+                <a:t>Computer vision and how it is used</a:t>
               </a:r>
-              <a:endParaRPr/>
+              <a:endParaRPr sz="700"/>
             </a:p>
           </p:txBody>
         </p:sp>
@@ -14371,8 +14367,8 @@
         </p:nvSpPr>
         <p:spPr>
           <a:xfrm>
-            <a:off x="952500" y="6154737"/>
-            <a:ext cx="12936537" cy="719137"/>
+            <a:off x="1054025" y="6221412"/>
+            <a:ext cx="12936600" cy="12960300"/>
           </a:xfrm>
           <a:prstGeom prst="rect">
             <a:avLst/>
@@ -14388,7 +14384,7 @@
           </a:bodyPr>
           <a:lstStyle/>
           <a:p>
-            <a:pPr indent="0" lvl="0" marL="0" marR="0" rtl="0" algn="l">
+            <a:pPr indent="0" lvl="0" marL="0" rtl="0" algn="just">
               <a:lnSpc>
                 <a:spcPct val="138888"/>
               </a:lnSpc>
@@ -14406,7 +14402,7 @@
               <a:buNone/>
             </a:pPr>
             <a:r>
-              <a:rPr b="0" i="0" lang="en-US" sz="3600" u="none">
+              <a:rPr lang="en-US" sz="3600">
                 <a:solidFill>
                   <a:schemeClr val="dk1"/>
                 </a:solidFill>
@@ -14415,9 +14411,88 @@
                 <a:cs typeface="Helvetica Neue"/>
                 <a:sym typeface="Helvetica Neue"/>
               </a:rPr>
-              <a:t>Text size 36pt Arial and exactly 50pt space between lines</a:t>
+              <a:t>Computer vision is a subfield of artificial intelligence, it provides to systems and machines the capability to process, analyse and interpret visual inputs like images and videos, mimicking human vision.  For example, in radiology imaging, radiologists carefully interpret chest X-rays in order to identify diseases such as breast cancer or pneumonia, in those cases, a computer vision system could help to detect early stages of breast cancer or to analyse pictures and videos to identify media manipulation or deepfakes.(Caballar and Stryker, 2025) </a:t>
             </a:r>
-            <a:endParaRPr/>
+            <a:endParaRPr sz="3600">
+              <a:solidFill>
+                <a:schemeClr val="dk1"/>
+              </a:solidFill>
+              <a:latin typeface="Helvetica Neue"/>
+              <a:ea typeface="Helvetica Neue"/>
+              <a:cs typeface="Helvetica Neue"/>
+              <a:sym typeface="Helvetica Neue"/>
+            </a:endParaRPr>
+          </a:p>
+          <a:p>
+            <a:pPr indent="0" lvl="0" marL="0" rtl="0" algn="just">
+              <a:lnSpc>
+                <a:spcPct val="138888"/>
+              </a:lnSpc>
+              <a:spcBef>
+                <a:spcPts val="0"/>
+              </a:spcBef>
+              <a:spcAft>
+                <a:spcPts val="0"/>
+              </a:spcAft>
+              <a:buClr>
+                <a:schemeClr val="dk1"/>
+              </a:buClr>
+              <a:buSzPts val="3600"/>
+              <a:buFont typeface="Helvetica Neue"/>
+              <a:buNone/>
+            </a:pPr>
+            <a:r>
+              <a:t/>
+            </a:r>
+            <a:endParaRPr sz="3600">
+              <a:solidFill>
+                <a:schemeClr val="dk1"/>
+              </a:solidFill>
+              <a:latin typeface="Helvetica Neue"/>
+              <a:ea typeface="Helvetica Neue"/>
+              <a:cs typeface="Helvetica Neue"/>
+              <a:sym typeface="Helvetica Neue"/>
+            </a:endParaRPr>
+          </a:p>
+          <a:p>
+            <a:pPr indent="0" lvl="0" marL="0" rtl="0" algn="just">
+              <a:lnSpc>
+                <a:spcPct val="138888"/>
+              </a:lnSpc>
+              <a:spcBef>
+                <a:spcPts val="0"/>
+              </a:spcBef>
+              <a:spcAft>
+                <a:spcPts val="0"/>
+              </a:spcAft>
+              <a:buClr>
+                <a:schemeClr val="dk1"/>
+              </a:buClr>
+              <a:buSzPts val="3600"/>
+              <a:buFont typeface="Helvetica Neue"/>
+              <a:buNone/>
+            </a:pPr>
+            <a:r>
+              <a:rPr lang="en-US" sz="3600">
+                <a:solidFill>
+                  <a:schemeClr val="dk1"/>
+                </a:solidFill>
+                <a:latin typeface="Helvetica Neue"/>
+                <a:ea typeface="Helvetica Neue"/>
+                <a:cs typeface="Helvetica Neue"/>
+                <a:sym typeface="Helvetica Neue"/>
+              </a:rPr>
+              <a:t>Furthermore, computer vision is used in various other areas, such as agriculture with drones monitoring crop health using sensors to detect diseases, pests and nutrient deficiencies as soon as those situations start emerging. Also in industrial environments, robots perform quality inspections identifying defects through image recognition and sensor based analysis.(Verma, 2025)</a:t>
+            </a:r>
+            <a:endParaRPr sz="3600">
+              <a:solidFill>
+                <a:schemeClr val="dk1"/>
+              </a:solidFill>
+              <a:latin typeface="Helvetica Neue"/>
+              <a:ea typeface="Helvetica Neue"/>
+              <a:cs typeface="Helvetica Neue"/>
+              <a:sym typeface="Helvetica Neue"/>
+            </a:endParaRPr>
           </a:p>
         </p:txBody>
       </p:sp>
@@ -14429,8 +14504,8 @@
         </p:nvSpPr>
         <p:spPr>
           <a:xfrm>
-            <a:off x="952500" y="15389225"/>
-            <a:ext cx="13100050" cy="719137"/>
+            <a:off x="977038" y="20837525"/>
+            <a:ext cx="13100100" cy="646500"/>
           </a:xfrm>
           <a:prstGeom prst="rect">
             <a:avLst/>
@@ -14539,8 +14614,8 @@
         </p:nvSpPr>
         <p:spPr>
           <a:xfrm>
-            <a:off x="15017750" y="21634450"/>
-            <a:ext cx="12787312" cy="517525"/>
+            <a:off x="15073313" y="26417975"/>
+            <a:ext cx="12787200" cy="461700"/>
           </a:xfrm>
           <a:prstGeom prst="rect">
             <a:avLst/>
@@ -14609,8 +14684,8 @@
         </p:nvSpPr>
         <p:spPr>
           <a:xfrm>
-            <a:off x="15109825" y="13462000"/>
-            <a:ext cx="517525" cy="646112"/>
+            <a:off x="15165388" y="18245525"/>
+            <a:ext cx="517500" cy="446400"/>
           </a:xfrm>
           <a:prstGeom prst="rect">
             <a:avLst/>
@@ -14661,8 +14736,8 @@
         </p:nvSpPr>
         <p:spPr>
           <a:xfrm>
-            <a:off x="15098712" y="13482637"/>
-            <a:ext cx="12660312" cy="8045450"/>
+            <a:off x="15154275" y="18266162"/>
+            <a:ext cx="12660300" cy="8045400"/>
           </a:xfrm>
           <a:prstGeom prst="rect">
             <a:avLst/>
@@ -14719,8 +14794,8 @@
         </p:nvSpPr>
         <p:spPr>
           <a:xfrm>
-            <a:off x="15109825" y="17833975"/>
-            <a:ext cx="517525" cy="647700"/>
+            <a:off x="15165388" y="22617500"/>
+            <a:ext cx="517500" cy="446400"/>
           </a:xfrm>
           <a:prstGeom prst="rect">
             <a:avLst/>
@@ -14772,7 +14847,7 @@
         <p:spPr>
           <a:xfrm>
             <a:off x="28943300" y="6221412"/>
-            <a:ext cx="12787312" cy="3898900"/>
+            <a:ext cx="12787200" cy="3898800"/>
           </a:xfrm>
           <a:prstGeom prst="rect">
             <a:avLst/>
@@ -14951,10 +15026,10 @@
         </p:nvGrpSpPr>
         <p:grpSpPr>
           <a:xfrm>
-            <a:off x="15016162" y="4975225"/>
-            <a:ext cx="12885737" cy="1108075"/>
+            <a:off x="15016255" y="4975370"/>
+            <a:ext cx="12885811" cy="1108011"/>
             <a:chOff x="14894284" y="5068979"/>
-            <a:chExt cx="12887106" cy="1107996"/>
+            <a:chExt cx="12887100" cy="1107900"/>
           </a:xfrm>
         </p:grpSpPr>
         <p:sp>
@@ -14966,7 +15041,7 @@
           <p:spPr>
             <a:xfrm>
               <a:off x="14894284" y="5068979"/>
-              <a:ext cx="12887106" cy="1107996"/>
+              <a:ext cx="12887100" cy="1107900"/>
             </a:xfrm>
             <a:prstGeom prst="rect">
               <a:avLst/>
@@ -15244,8 +15319,8 @@
         </p:nvGrpSpPr>
         <p:grpSpPr>
           <a:xfrm>
-            <a:off x="28917900" y="4972050"/>
-            <a:ext cx="12885737" cy="1108075"/>
+            <a:off x="28917993" y="4972195"/>
+            <a:ext cx="12885817" cy="1108107"/>
             <a:chOff x="14894284" y="5068979"/>
             <a:chExt cx="12887106" cy="1107996"/>
           </a:xfrm>
@@ -15344,7 +15419,7 @@
         <p:spPr>
           <a:xfrm>
             <a:off x="14998700" y="6154737"/>
-            <a:ext cx="12936537" cy="719137"/>
+            <a:ext cx="12936600" cy="719100"/>
           </a:xfrm>
           <a:prstGeom prst="rect">
             <a:avLst/>
@@ -15657,6 +15732,285 @@
 </file>
 
 <file path=ppt/theme/theme1.xml><?xml version="1.0" encoding="utf-8"?>
+<a:theme xmlns:a="http://schemas.openxmlformats.org/drawingml/2006/main" xmlns:r="http://schemas.openxmlformats.org/officeDocument/2006/relationships" name="Default Design">
+  <a:themeElements>
+    <a:clrScheme name="Custom 1">
+      <a:dk1>
+        <a:srgbClr val="000000"/>
+      </a:dk1>
+      <a:lt1>
+        <a:srgbClr val="FFFFFF"/>
+      </a:lt1>
+      <a:dk2>
+        <a:srgbClr val="000000"/>
+      </a:dk2>
+      <a:lt2>
+        <a:srgbClr val="808080"/>
+      </a:lt2>
+      <a:accent1>
+        <a:srgbClr val="D11242"/>
+      </a:accent1>
+      <a:accent2>
+        <a:srgbClr val="3333CC"/>
+      </a:accent2>
+      <a:accent3>
+        <a:srgbClr val="FFFFFF"/>
+      </a:accent3>
+      <a:accent4>
+        <a:srgbClr val="000000"/>
+      </a:accent4>
+      <a:accent5>
+        <a:srgbClr val="AAE2CA"/>
+      </a:accent5>
+      <a:accent6>
+        <a:srgbClr val="2D2DB9"/>
+      </a:accent6>
+      <a:hlink>
+        <a:srgbClr val="CCCCFF"/>
+      </a:hlink>
+      <a:folHlink>
+        <a:srgbClr val="B2B2B2"/>
+      </a:folHlink>
+    </a:clrScheme>
+    <a:fontScheme name="Office">
+      <a:majorFont>
+        <a:latin typeface="Arial"/>
+        <a:ea typeface=""/>
+        <a:cs typeface=""/>
+        <a:font script="Jpan" typeface="ＭＳ Ｐゴシック"/>
+        <a:font script="Hang" typeface="맑은 고딕"/>
+        <a:font script="Hans" typeface="宋体"/>
+        <a:font script="Hant" typeface="新細明體"/>
+        <a:font script="Arab" typeface="Times New Roman"/>
+        <a:font script="Hebr" typeface="Times New Roman"/>
+        <a:font script="Thai" typeface="Angsana New"/>
+        <a:font script="Ethi" typeface="Nyala"/>
+        <a:font script="Beng" typeface="Vrinda"/>
+        <a:font script="Gujr" typeface="Shruti"/>
+        <a:font script="Khmr" typeface="MoolBoran"/>
+        <a:font script="Knda" typeface="Tunga"/>
+        <a:font script="Guru" typeface="Raavi"/>
+        <a:font script="Cans" typeface="Euphemia"/>
+        <a:font script="Cher" typeface="Plantagenet Cherokee"/>
+        <a:font script="Yiii" typeface="Microsoft Yi Baiti"/>
+        <a:font script="Tibt" typeface="Microsoft Himalaya"/>
+        <a:font script="Thaa" typeface="MV Boli"/>
+        <a:font script="Deva" typeface="Mangal"/>
+        <a:font script="Telu" typeface="Gautami"/>
+        <a:font script="Taml" typeface="Latha"/>
+        <a:font script="Syrc" typeface="Estrangelo Edessa"/>
+        <a:font script="Orya" typeface="Kalinga"/>
+        <a:font script="Mlym" typeface="Kartika"/>
+        <a:font script="Laoo" typeface="DokChampa"/>
+        <a:font script="Sinh" typeface="Iskoola Pota"/>
+        <a:font script="Mong" typeface="Mongolian Baiti"/>
+        <a:font script="Viet" typeface="Times New Roman"/>
+        <a:font script="Uigh" typeface="Microsoft Uighur"/>
+        <a:font script="Geor" typeface="Sylfaen"/>
+      </a:majorFont>
+      <a:minorFont>
+        <a:latin typeface="Arial"/>
+        <a:ea typeface=""/>
+        <a:cs typeface=""/>
+        <a:font script="Jpan" typeface="ＭＳ Ｐゴシック"/>
+        <a:font script="Hang" typeface="맑은 고딕"/>
+        <a:font script="Hans" typeface="宋体"/>
+        <a:font script="Hant" typeface="新細明體"/>
+        <a:font script="Arab" typeface="Arial"/>
+        <a:font script="Hebr" typeface="Arial"/>
+        <a:font script="Thai" typeface="Cordia New"/>
+        <a:font script="Ethi" typeface="Nyala"/>
+        <a:font script="Beng" typeface="Vrinda"/>
+        <a:font script="Gujr" typeface="Shruti"/>
+        <a:font script="Khmr" typeface="DaunPenh"/>
+        <a:font script="Knda" typeface="Tunga"/>
+        <a:font script="Guru" typeface="Raavi"/>
+        <a:font script="Cans" typeface="Euphemia"/>
+        <a:font script="Cher" typeface="Plantagenet Cherokee"/>
+        <a:font script="Yiii" typeface="Microsoft Yi Baiti"/>
+        <a:font script="Tibt" typeface="Microsoft Himalaya"/>
+        <a:font script="Thaa" typeface="MV Boli"/>
+        <a:font script="Deva" typeface="Mangal"/>
+        <a:font script="Telu" typeface="Gautami"/>
+        <a:font script="Taml" typeface="Latha"/>
+        <a:font script="Syrc" typeface="Estrangelo Edessa"/>
+        <a:font script="Orya" typeface="Kalinga"/>
+        <a:font script="Mlym" typeface="Kartika"/>
+        <a:font script="Laoo" typeface="DokChampa"/>
+        <a:font script="Sinh" typeface="Iskoola Pota"/>
+        <a:font script="Mong" typeface="Mongolian Baiti"/>
+        <a:font script="Viet" typeface="Arial"/>
+        <a:font script="Uigh" typeface="Microsoft Uighur"/>
+        <a:font script="Geor" typeface="Sylfaen"/>
+      </a:minorFont>
+    </a:fontScheme>
+    <a:fmtScheme name="Office">
+      <a:fillStyleLst>
+        <a:solidFill>
+          <a:schemeClr val="phClr"/>
+        </a:solidFill>
+        <a:gradFill rotWithShape="1">
+          <a:gsLst>
+            <a:gs pos="0">
+              <a:schemeClr val="phClr">
+                <a:tint val="50000"/>
+                <a:satMod val="300000"/>
+              </a:schemeClr>
+            </a:gs>
+            <a:gs pos="35000">
+              <a:schemeClr val="phClr">
+                <a:tint val="37000"/>
+                <a:satMod val="300000"/>
+              </a:schemeClr>
+            </a:gs>
+            <a:gs pos="100000">
+              <a:schemeClr val="phClr">
+                <a:tint val="15000"/>
+                <a:satMod val="350000"/>
+              </a:schemeClr>
+            </a:gs>
+          </a:gsLst>
+          <a:lin ang="16200000" scaled="1"/>
+        </a:gradFill>
+        <a:gradFill rotWithShape="1">
+          <a:gsLst>
+            <a:gs pos="0">
+              <a:schemeClr val="phClr">
+                <a:tint val="100000"/>
+                <a:shade val="100000"/>
+                <a:satMod val="130000"/>
+              </a:schemeClr>
+            </a:gs>
+            <a:gs pos="100000">
+              <a:schemeClr val="phClr">
+                <a:tint val="50000"/>
+                <a:shade val="100000"/>
+                <a:satMod val="350000"/>
+              </a:schemeClr>
+            </a:gs>
+          </a:gsLst>
+          <a:lin ang="16200000" scaled="0"/>
+        </a:gradFill>
+      </a:fillStyleLst>
+      <a:lnStyleLst>
+        <a:ln w="9525" cap="flat" cmpd="sng" algn="ctr">
+          <a:solidFill>
+            <a:schemeClr val="phClr">
+              <a:shade val="95000"/>
+              <a:satMod val="105000"/>
+            </a:schemeClr>
+          </a:solidFill>
+          <a:prstDash val="solid"/>
+        </a:ln>
+        <a:ln w="25400" cap="flat" cmpd="sng" algn="ctr">
+          <a:solidFill>
+            <a:schemeClr val="phClr"/>
+          </a:solidFill>
+          <a:prstDash val="solid"/>
+        </a:ln>
+        <a:ln w="38100" cap="flat" cmpd="sng" algn="ctr">
+          <a:solidFill>
+            <a:schemeClr val="phClr"/>
+          </a:solidFill>
+          <a:prstDash val="solid"/>
+        </a:ln>
+      </a:lnStyleLst>
+      <a:effectStyleLst>
+        <a:effectStyle>
+          <a:effectLst>
+            <a:outerShdw blurRad="40000" dist="20000" dir="5400000" rotWithShape="0">
+              <a:srgbClr val="000000">
+                <a:alpha val="38000"/>
+              </a:srgbClr>
+            </a:outerShdw>
+          </a:effectLst>
+        </a:effectStyle>
+        <a:effectStyle>
+          <a:effectLst>
+            <a:outerShdw blurRad="40000" dist="23000" dir="5400000" rotWithShape="0">
+              <a:srgbClr val="000000">
+                <a:alpha val="35000"/>
+              </a:srgbClr>
+            </a:outerShdw>
+          </a:effectLst>
+        </a:effectStyle>
+        <a:effectStyle>
+          <a:effectLst>
+            <a:outerShdw blurRad="40000" dist="23000" dir="5400000" rotWithShape="0">
+              <a:srgbClr val="000000">
+                <a:alpha val="35000"/>
+              </a:srgbClr>
+            </a:outerShdw>
+          </a:effectLst>
+          <a:scene3d>
+            <a:camera prst="orthographicFront">
+              <a:rot lat="0" lon="0" rev="0"/>
+            </a:camera>
+            <a:lightRig rig="threePt" dir="t">
+              <a:rot lat="0" lon="0" rev="1200000"/>
+            </a:lightRig>
+          </a:scene3d>
+          <a:sp3d>
+            <a:bevelT w="63500" h="25400"/>
+          </a:sp3d>
+        </a:effectStyle>
+      </a:effectStyleLst>
+      <a:bgFillStyleLst>
+        <a:solidFill>
+          <a:schemeClr val="phClr"/>
+        </a:solidFill>
+        <a:gradFill rotWithShape="1">
+          <a:gsLst>
+            <a:gs pos="0">
+              <a:schemeClr val="phClr">
+                <a:tint val="40000"/>
+                <a:satMod val="350000"/>
+              </a:schemeClr>
+            </a:gs>
+            <a:gs pos="40000">
+              <a:schemeClr val="phClr">
+                <a:tint val="45000"/>
+                <a:shade val="99000"/>
+                <a:satMod val="350000"/>
+              </a:schemeClr>
+            </a:gs>
+            <a:gs pos="100000">
+              <a:schemeClr val="phClr">
+                <a:shade val="20000"/>
+                <a:satMod val="255000"/>
+              </a:schemeClr>
+            </a:gs>
+          </a:gsLst>
+          <a:path path="circle">
+            <a:fillToRect l="50000" t="-80000" r="50000" b="180000"/>
+          </a:path>
+        </a:gradFill>
+        <a:gradFill rotWithShape="1">
+          <a:gsLst>
+            <a:gs pos="0">
+              <a:schemeClr val="phClr">
+                <a:tint val="80000"/>
+                <a:satMod val="300000"/>
+              </a:schemeClr>
+            </a:gs>
+            <a:gs pos="100000">
+              <a:schemeClr val="phClr">
+                <a:shade val="30000"/>
+                <a:satMod val="200000"/>
+              </a:schemeClr>
+            </a:gs>
+          </a:gsLst>
+          <a:path path="circle">
+            <a:fillToRect l="50000" t="50000" r="50000" b="50000"/>
+          </a:path>
+        </a:gradFill>
+      </a:bgFillStyleLst>
+    </a:fmtScheme>
+  </a:themeElements>
+</a:theme>
+</file>
+
+<file path=ppt/theme/theme2.xml><?xml version="1.0" encoding="utf-8"?>
 <a:theme xmlns:a="http://schemas.openxmlformats.org/drawingml/2006/main" xmlns:r="http://schemas.openxmlformats.org/officeDocument/2006/relationships">
   <a:themeElements>
     <a:clrScheme name="Default">
@@ -15933,283 +16287,4 @@
     </a:fmtScheme>
   </a:themeElements>
 </a:theme>
-</file>
-
-<file path=ppt/theme/theme2.xml><?xml version="1.0" encoding="utf-8"?>
-<a:theme xmlns:a="http://schemas.openxmlformats.org/drawingml/2006/main" xmlns:r="http://schemas.openxmlformats.org/officeDocument/2006/relationships" name="Default Design">
-  <a:themeElements>
-    <a:clrScheme name="Custom 1">
-      <a:dk1>
-        <a:srgbClr val="000000"/>
-      </a:dk1>
-      <a:lt1>
-        <a:srgbClr val="FFFFFF"/>
-      </a:lt1>
-      <a:dk2>
-        <a:srgbClr val="000000"/>
-      </a:dk2>
-      <a:lt2>
-        <a:srgbClr val="808080"/>
-      </a:lt2>
-      <a:accent1>
-        <a:srgbClr val="D11242"/>
-      </a:accent1>
-      <a:accent2>
-        <a:srgbClr val="3333CC"/>
-      </a:accent2>
-      <a:accent3>
-        <a:srgbClr val="FFFFFF"/>
-      </a:accent3>
-      <a:accent4>
-        <a:srgbClr val="000000"/>
-      </a:accent4>
-      <a:accent5>
-        <a:srgbClr val="AAE2CA"/>
-      </a:accent5>
-      <a:accent6>
-        <a:srgbClr val="2D2DB9"/>
-      </a:accent6>
-      <a:hlink>
-        <a:srgbClr val="CCCCFF"/>
-      </a:hlink>
-      <a:folHlink>
-        <a:srgbClr val="B2B2B2"/>
-      </a:folHlink>
-    </a:clrScheme>
-    <a:fontScheme name="Office">
-      <a:majorFont>
-        <a:latin typeface="Arial"/>
-        <a:ea typeface=""/>
-        <a:cs typeface=""/>
-        <a:font script="Jpan" typeface="ＭＳ Ｐゴシック"/>
-        <a:font script="Hang" typeface="맑은 고딕"/>
-        <a:font script="Hans" typeface="宋体"/>
-        <a:font script="Hant" typeface="新細明體"/>
-        <a:font script="Arab" typeface="Times New Roman"/>
-        <a:font script="Hebr" typeface="Times New Roman"/>
-        <a:font script="Thai" typeface="Angsana New"/>
-        <a:font script="Ethi" typeface="Nyala"/>
-        <a:font script="Beng" typeface="Vrinda"/>
-        <a:font script="Gujr" typeface="Shruti"/>
-        <a:font script="Khmr" typeface="MoolBoran"/>
-        <a:font script="Knda" typeface="Tunga"/>
-        <a:font script="Guru" typeface="Raavi"/>
-        <a:font script="Cans" typeface="Euphemia"/>
-        <a:font script="Cher" typeface="Plantagenet Cherokee"/>
-        <a:font script="Yiii" typeface="Microsoft Yi Baiti"/>
-        <a:font script="Tibt" typeface="Microsoft Himalaya"/>
-        <a:font script="Thaa" typeface="MV Boli"/>
-        <a:font script="Deva" typeface="Mangal"/>
-        <a:font script="Telu" typeface="Gautami"/>
-        <a:font script="Taml" typeface="Latha"/>
-        <a:font script="Syrc" typeface="Estrangelo Edessa"/>
-        <a:font script="Orya" typeface="Kalinga"/>
-        <a:font script="Mlym" typeface="Kartika"/>
-        <a:font script="Laoo" typeface="DokChampa"/>
-        <a:font script="Sinh" typeface="Iskoola Pota"/>
-        <a:font script="Mong" typeface="Mongolian Baiti"/>
-        <a:font script="Viet" typeface="Times New Roman"/>
-        <a:font script="Uigh" typeface="Microsoft Uighur"/>
-        <a:font script="Geor" typeface="Sylfaen"/>
-      </a:majorFont>
-      <a:minorFont>
-        <a:latin typeface="Arial"/>
-        <a:ea typeface=""/>
-        <a:cs typeface=""/>
-        <a:font script="Jpan" typeface="ＭＳ Ｐゴシック"/>
-        <a:font script="Hang" typeface="맑은 고딕"/>
-        <a:font script="Hans" typeface="宋体"/>
-        <a:font script="Hant" typeface="新細明體"/>
-        <a:font script="Arab" typeface="Arial"/>
-        <a:font script="Hebr" typeface="Arial"/>
-        <a:font script="Thai" typeface="Cordia New"/>
-        <a:font script="Ethi" typeface="Nyala"/>
-        <a:font script="Beng" typeface="Vrinda"/>
-        <a:font script="Gujr" typeface="Shruti"/>
-        <a:font script="Khmr" typeface="DaunPenh"/>
-        <a:font script="Knda" typeface="Tunga"/>
-        <a:font script="Guru" typeface="Raavi"/>
-        <a:font script="Cans" typeface="Euphemia"/>
-        <a:font script="Cher" typeface="Plantagenet Cherokee"/>
-        <a:font script="Yiii" typeface="Microsoft Yi Baiti"/>
-        <a:font script="Tibt" typeface="Microsoft Himalaya"/>
-        <a:font script="Thaa" typeface="MV Boli"/>
-        <a:font script="Deva" typeface="Mangal"/>
-        <a:font script="Telu" typeface="Gautami"/>
-        <a:font script="Taml" typeface="Latha"/>
-        <a:font script="Syrc" typeface="Estrangelo Edessa"/>
-        <a:font script="Orya" typeface="Kalinga"/>
-        <a:font script="Mlym" typeface="Kartika"/>
-        <a:font script="Laoo" typeface="DokChampa"/>
-        <a:font script="Sinh" typeface="Iskoola Pota"/>
-        <a:font script="Mong" typeface="Mongolian Baiti"/>
-        <a:font script="Viet" typeface="Arial"/>
-        <a:font script="Uigh" typeface="Microsoft Uighur"/>
-        <a:font script="Geor" typeface="Sylfaen"/>
-      </a:minorFont>
-    </a:fontScheme>
-    <a:fmtScheme name="Office">
-      <a:fillStyleLst>
-        <a:solidFill>
-          <a:schemeClr val="phClr"/>
-        </a:solidFill>
-        <a:gradFill rotWithShape="1">
-          <a:gsLst>
-            <a:gs pos="0">
-              <a:schemeClr val="phClr">
-                <a:tint val="50000"/>
-                <a:satMod val="300000"/>
-              </a:schemeClr>
-            </a:gs>
-            <a:gs pos="35000">
-              <a:schemeClr val="phClr">
-                <a:tint val="37000"/>
-                <a:satMod val="300000"/>
-              </a:schemeClr>
-            </a:gs>
-            <a:gs pos="100000">
-              <a:schemeClr val="phClr">
-                <a:tint val="15000"/>
-                <a:satMod val="350000"/>
-              </a:schemeClr>
-            </a:gs>
-          </a:gsLst>
-          <a:lin ang="16200000" scaled="1"/>
-        </a:gradFill>
-        <a:gradFill rotWithShape="1">
-          <a:gsLst>
-            <a:gs pos="0">
-              <a:schemeClr val="phClr">
-                <a:tint val="100000"/>
-                <a:shade val="100000"/>
-                <a:satMod val="130000"/>
-              </a:schemeClr>
-            </a:gs>
-            <a:gs pos="100000">
-              <a:schemeClr val="phClr">
-                <a:tint val="50000"/>
-                <a:shade val="100000"/>
-                <a:satMod val="350000"/>
-              </a:schemeClr>
-            </a:gs>
-          </a:gsLst>
-          <a:lin ang="16200000" scaled="0"/>
-        </a:gradFill>
-      </a:fillStyleLst>
-      <a:lnStyleLst>
-        <a:ln w="9525" cap="flat" cmpd="sng" algn="ctr">
-          <a:solidFill>
-            <a:schemeClr val="phClr">
-              <a:shade val="95000"/>
-              <a:satMod val="105000"/>
-            </a:schemeClr>
-          </a:solidFill>
-          <a:prstDash val="solid"/>
-        </a:ln>
-        <a:ln w="25400" cap="flat" cmpd="sng" algn="ctr">
-          <a:solidFill>
-            <a:schemeClr val="phClr"/>
-          </a:solidFill>
-          <a:prstDash val="solid"/>
-        </a:ln>
-        <a:ln w="38100" cap="flat" cmpd="sng" algn="ctr">
-          <a:solidFill>
-            <a:schemeClr val="phClr"/>
-          </a:solidFill>
-          <a:prstDash val="solid"/>
-        </a:ln>
-      </a:lnStyleLst>
-      <a:effectStyleLst>
-        <a:effectStyle>
-          <a:effectLst>
-            <a:outerShdw blurRad="40000" dist="20000" dir="5400000" rotWithShape="0">
-              <a:srgbClr val="000000">
-                <a:alpha val="38000"/>
-              </a:srgbClr>
-            </a:outerShdw>
-          </a:effectLst>
-        </a:effectStyle>
-        <a:effectStyle>
-          <a:effectLst>
-            <a:outerShdw blurRad="40000" dist="23000" dir="5400000" rotWithShape="0">
-              <a:srgbClr val="000000">
-                <a:alpha val="35000"/>
-              </a:srgbClr>
-            </a:outerShdw>
-          </a:effectLst>
-        </a:effectStyle>
-        <a:effectStyle>
-          <a:effectLst>
-            <a:outerShdw blurRad="40000" dist="23000" dir="5400000" rotWithShape="0">
-              <a:srgbClr val="000000">
-                <a:alpha val="35000"/>
-              </a:srgbClr>
-            </a:outerShdw>
-          </a:effectLst>
-          <a:scene3d>
-            <a:camera prst="orthographicFront">
-              <a:rot lat="0" lon="0" rev="0"/>
-            </a:camera>
-            <a:lightRig rig="threePt" dir="t">
-              <a:rot lat="0" lon="0" rev="1200000"/>
-            </a:lightRig>
-          </a:scene3d>
-          <a:sp3d>
-            <a:bevelT w="63500" h="25400"/>
-          </a:sp3d>
-        </a:effectStyle>
-      </a:effectStyleLst>
-      <a:bgFillStyleLst>
-        <a:solidFill>
-          <a:schemeClr val="phClr"/>
-        </a:solidFill>
-        <a:gradFill rotWithShape="1">
-          <a:gsLst>
-            <a:gs pos="0">
-              <a:schemeClr val="phClr">
-                <a:tint val="40000"/>
-                <a:satMod val="350000"/>
-              </a:schemeClr>
-            </a:gs>
-            <a:gs pos="40000">
-              <a:schemeClr val="phClr">
-                <a:tint val="45000"/>
-                <a:shade val="99000"/>
-                <a:satMod val="350000"/>
-              </a:schemeClr>
-            </a:gs>
-            <a:gs pos="100000">
-              <a:schemeClr val="phClr">
-                <a:shade val="20000"/>
-                <a:satMod val="255000"/>
-              </a:schemeClr>
-            </a:gs>
-          </a:gsLst>
-          <a:path path="circle">
-            <a:fillToRect l="50000" t="-80000" r="50000" b="180000"/>
-          </a:path>
-        </a:gradFill>
-        <a:gradFill rotWithShape="1">
-          <a:gsLst>
-            <a:gs pos="0">
-              <a:schemeClr val="phClr">
-                <a:tint val="80000"/>
-                <a:satMod val="300000"/>
-              </a:schemeClr>
-            </a:gs>
-            <a:gs pos="100000">
-              <a:schemeClr val="phClr">
-                <a:shade val="30000"/>
-                <a:satMod val="200000"/>
-              </a:schemeClr>
-            </a:gs>
-          </a:gsLst>
-          <a:path path="circle">
-            <a:fillToRect l="50000" t="50000" r="50000" b="50000"/>
-          </a:path>
-        </a:gradFill>
-      </a:bgFillStyleLst>
-    </a:fmtScheme>
-  </a:themeElements>
-</a:theme>
 </file>
</xml_diff>

<commit_message>
Ethical, legal and social impacts
</commit_message>
<xml_diff>
--- a/2023263 AI CA1.pptx
+++ b/2023263 AI CA1.pptx
@@ -14174,9 +14174,9 @@
         <p:grpSpPr>
           <a:xfrm>
             <a:off x="967496" y="19544178"/>
-            <a:ext cx="12887106" cy="1108011"/>
+            <a:ext cx="12887106" cy="2124212"/>
             <a:chOff x="943194" y="16253059"/>
-            <a:chExt cx="12887106" cy="1107900"/>
+            <a:chExt cx="12887106" cy="2124000"/>
           </a:xfrm>
         </p:grpSpPr>
         <p:sp>
@@ -14188,7 +14188,7 @@
           <p:spPr>
             <a:xfrm>
               <a:off x="943194" y="16253059"/>
-              <a:ext cx="12887100" cy="1107900"/>
+              <a:ext cx="12887100" cy="2124000"/>
             </a:xfrm>
             <a:prstGeom prst="rect">
               <a:avLst/>
@@ -14222,16 +14222,12 @@
                 <a:buNone/>
               </a:pPr>
               <a:r>
-                <a:rPr b="1" i="0" lang="en-US" sz="6600" u="none">
+                <a:rPr b="1" lang="en-US" sz="6600">
                   <a:solidFill>
                     <a:srgbClr val="006684"/>
                   </a:solidFill>
-                  <a:latin typeface="Arial"/>
-                  <a:ea typeface="Arial"/>
-                  <a:cs typeface="Arial"/>
-                  <a:sym typeface="Arial"/>
                 </a:rPr>
-                <a:t>Methods</a:t>
+                <a:t>Ethical, legal and social impacts of Computer vision</a:t>
               </a:r>
               <a:endParaRPr/>
             </a:p>
@@ -14504,8 +14500,8 @@
         </p:nvSpPr>
         <p:spPr>
           <a:xfrm>
-            <a:off x="977038" y="20837525"/>
-            <a:ext cx="13100100" cy="646500"/>
+            <a:off x="972263" y="21729900"/>
+            <a:ext cx="13100100" cy="6033900"/>
           </a:xfrm>
           <a:prstGeom prst="rect">
             <a:avLst/>
@@ -14539,7 +14535,7 @@
               <a:buNone/>
             </a:pPr>
             <a:r>
-              <a:rPr b="0" i="0" lang="en-US" sz="3600" u="none">
+              <a:rPr lang="en-US" sz="3600">
                 <a:solidFill>
                   <a:schemeClr val="dk1"/>
                 </a:solidFill>
@@ -14548,7 +14544,7 @@
                 <a:cs typeface="Helvetica Neue"/>
                 <a:sym typeface="Helvetica Neue"/>
               </a:rPr>
-              <a:t>Text size 36pt Arial and exactly 50pt space between lines</a:t>
+              <a:t>Due to rapid advances of AI, deepfake technology has been changing digital media creation and manipulation. As it becomes more and more accessible, individuals with limited technical expertise are now able to generate convincing manipulated videos, this led to a rise in harmful uses, such as scams impersonating individuals, spread of misinformation, fabricated political statements, and manipulation of digital evidence.(Priyanga et al., 2026, p.1)</a:t>
             </a:r>
             <a:endParaRPr/>
           </a:p>
@@ -15026,7 +15022,7 @@
         </p:nvGrpSpPr>
         <p:grpSpPr>
           <a:xfrm>
-            <a:off x="15016255" y="4975370"/>
+            <a:off x="15033717" y="11476908"/>
             <a:ext cx="12885811" cy="1108011"/>
             <a:chOff x="14894284" y="5068979"/>
             <a:chExt cx="12887100" cy="1107900"/>
@@ -15418,8 +15414,8 @@
         </p:nvSpPr>
         <p:spPr>
           <a:xfrm>
-            <a:off x="14998700" y="6154737"/>
-            <a:ext cx="12936600" cy="719100"/>
+            <a:off x="15016163" y="12656275"/>
+            <a:ext cx="12936600" cy="646500"/>
           </a:xfrm>
           <a:prstGeom prst="rect">
             <a:avLst/>
@@ -15723,6 +15719,64 @@
           </a:ln>
         </p:spPr>
       </p:pic>
+      <p:sp>
+        <p:nvSpPr>
+          <p:cNvPr id="119" name="Google Shape;119;p13"/>
+          <p:cNvSpPr txBox="1"/>
+          <p:nvPr/>
+        </p:nvSpPr>
+        <p:spPr>
+          <a:xfrm>
+            <a:off x="15016163" y="5141149"/>
+            <a:ext cx="12936600" cy="6033900"/>
+          </a:xfrm>
+          <a:prstGeom prst="rect">
+            <a:avLst/>
+          </a:prstGeom>
+          <a:noFill/>
+          <a:ln>
+            <a:noFill/>
+          </a:ln>
+        </p:spPr>
+        <p:txBody>
+          <a:bodyPr anchorCtr="0" anchor="t" bIns="45700" lIns="91425" spcFirstLastPara="1" rIns="91425" wrap="square" tIns="45700">
+            <a:spAutoFit/>
+          </a:bodyPr>
+          <a:lstStyle/>
+          <a:p>
+            <a:pPr indent="0" lvl="0" marL="0" marR="0" rtl="0" algn="just">
+              <a:lnSpc>
+                <a:spcPct val="138888"/>
+              </a:lnSpc>
+              <a:spcBef>
+                <a:spcPts val="0"/>
+              </a:spcBef>
+              <a:spcAft>
+                <a:spcPts val="0"/>
+              </a:spcAft>
+              <a:buClr>
+                <a:schemeClr val="dk1"/>
+              </a:buClr>
+              <a:buSzPts val="3600"/>
+              <a:buFont typeface="Helvetica Neue"/>
+              <a:buNone/>
+            </a:pPr>
+            <a:r>
+              <a:rPr lang="en-US" sz="3600">
+                <a:solidFill>
+                  <a:schemeClr val="dk1"/>
+                </a:solidFill>
+                <a:latin typeface="Helvetica Neue"/>
+                <a:ea typeface="Helvetica Neue"/>
+                <a:cs typeface="Helvetica Neue"/>
+                <a:sym typeface="Helvetica Neue"/>
+              </a:rPr>
+              <a:t>However deep learning has evolved as the solution for detecting deepfake media. In this case, convolutional neural networks(CNNs) are specifically effective in this task due to being able to automatically learn hierarchical feature representations from images. By identifying subtle inconsistencies in facial textures, lighting patterns and spatial structures, deepfake media can be detected.(Priyanga et al., 2026, p.1)</a:t>
+            </a:r>
+            <a:endParaRPr/>
+          </a:p>
+        </p:txBody>
+      </p:sp>
     </p:spTree>
   </p:cSld>
   <p:clrMapOvr>
@@ -15732,6 +15786,285 @@
 </file>
 
 <file path=ppt/theme/theme1.xml><?xml version="1.0" encoding="utf-8"?>
+<a:theme xmlns:a="http://schemas.openxmlformats.org/drawingml/2006/main" xmlns:r="http://schemas.openxmlformats.org/officeDocument/2006/relationships">
+  <a:themeElements>
+    <a:clrScheme name="Default">
+      <a:dk1>
+        <a:srgbClr val="000000"/>
+      </a:dk1>
+      <a:lt1>
+        <a:srgbClr val="FFFFFF"/>
+      </a:lt1>
+      <a:dk2>
+        <a:srgbClr val="158158"/>
+      </a:dk2>
+      <a:lt2>
+        <a:srgbClr val="F3F3F3"/>
+      </a:lt2>
+      <a:accent1>
+        <a:srgbClr val="058DC7"/>
+      </a:accent1>
+      <a:accent2>
+        <a:srgbClr val="50B432"/>
+      </a:accent2>
+      <a:accent3>
+        <a:srgbClr val="ED561B"/>
+      </a:accent3>
+      <a:accent4>
+        <a:srgbClr val="EDEF00"/>
+      </a:accent4>
+      <a:accent5>
+        <a:srgbClr val="24CBE5"/>
+      </a:accent5>
+      <a:accent6>
+        <a:srgbClr val="64E572"/>
+      </a:accent6>
+      <a:hlink>
+        <a:srgbClr val="2200CC"/>
+      </a:hlink>
+      <a:folHlink>
+        <a:srgbClr val="551A8B"/>
+      </a:folHlink>
+    </a:clrScheme>
+    <a:fontScheme name="Office">
+      <a:majorFont>
+        <a:latin typeface="Arial"/>
+        <a:ea typeface=""/>
+        <a:cs typeface=""/>
+        <a:font script="Jpan" typeface="ＭＳ Ｐゴシック"/>
+        <a:font script="Hang" typeface="맑은 고딕"/>
+        <a:font script="Hans" typeface="宋体"/>
+        <a:font script="Hant" typeface="新細明體"/>
+        <a:font script="Arab" typeface="Times New Roman"/>
+        <a:font script="Hebr" typeface="Times New Roman"/>
+        <a:font script="Thai" typeface="Angsana New"/>
+        <a:font script="Ethi" typeface="Nyala"/>
+        <a:font script="Beng" typeface="Vrinda"/>
+        <a:font script="Gujr" typeface="Shruti"/>
+        <a:font script="Khmr" typeface="MoolBoran"/>
+        <a:font script="Knda" typeface="Tunga"/>
+        <a:font script="Guru" typeface="Raavi"/>
+        <a:font script="Cans" typeface="Euphemia"/>
+        <a:font script="Cher" typeface="Plantagenet Cherokee"/>
+        <a:font script="Yiii" typeface="Microsoft Yi Baiti"/>
+        <a:font script="Tibt" typeface="Microsoft Himalaya"/>
+        <a:font script="Thaa" typeface="MV Boli"/>
+        <a:font script="Deva" typeface="Mangal"/>
+        <a:font script="Telu" typeface="Gautami"/>
+        <a:font script="Taml" typeface="Latha"/>
+        <a:font script="Syrc" typeface="Estrangelo Edessa"/>
+        <a:font script="Orya" typeface="Kalinga"/>
+        <a:font script="Mlym" typeface="Kartika"/>
+        <a:font script="Laoo" typeface="DokChampa"/>
+        <a:font script="Sinh" typeface="Iskoola Pota"/>
+        <a:font script="Mong" typeface="Mongolian Baiti"/>
+        <a:font script="Viet" typeface="Times New Roman"/>
+        <a:font script="Uigh" typeface="Microsoft Uighur"/>
+        <a:font script="Geor" typeface="Sylfaen"/>
+      </a:majorFont>
+      <a:minorFont>
+        <a:latin typeface="Arial"/>
+        <a:ea typeface=""/>
+        <a:cs typeface=""/>
+        <a:font script="Jpan" typeface="ＭＳ Ｐゴシック"/>
+        <a:font script="Hang" typeface="맑은 고딕"/>
+        <a:font script="Hans" typeface="宋体"/>
+        <a:font script="Hant" typeface="新細明體"/>
+        <a:font script="Arab" typeface="Arial"/>
+        <a:font script="Hebr" typeface="Arial"/>
+        <a:font script="Thai" typeface="Cordia New"/>
+        <a:font script="Ethi" typeface="Nyala"/>
+        <a:font script="Beng" typeface="Vrinda"/>
+        <a:font script="Gujr" typeface="Shruti"/>
+        <a:font script="Khmr" typeface="DaunPenh"/>
+        <a:font script="Knda" typeface="Tunga"/>
+        <a:font script="Guru" typeface="Raavi"/>
+        <a:font script="Cans" typeface="Euphemia"/>
+        <a:font script="Cher" typeface="Plantagenet Cherokee"/>
+        <a:font script="Yiii" typeface="Microsoft Yi Baiti"/>
+        <a:font script="Tibt" typeface="Microsoft Himalaya"/>
+        <a:font script="Thaa" typeface="MV Boli"/>
+        <a:font script="Deva" typeface="Mangal"/>
+        <a:font script="Telu" typeface="Gautami"/>
+        <a:font script="Taml" typeface="Latha"/>
+        <a:font script="Syrc" typeface="Estrangelo Edessa"/>
+        <a:font script="Orya" typeface="Kalinga"/>
+        <a:font script="Mlym" typeface="Kartika"/>
+        <a:font script="Laoo" typeface="DokChampa"/>
+        <a:font script="Sinh" typeface="Iskoola Pota"/>
+        <a:font script="Mong" typeface="Mongolian Baiti"/>
+        <a:font script="Viet" typeface="Arial"/>
+        <a:font script="Uigh" typeface="Microsoft Uighur"/>
+        <a:font script="Geor" typeface="Sylfaen"/>
+      </a:minorFont>
+    </a:fontScheme>
+    <a:fmtScheme name="Office">
+      <a:fillStyleLst>
+        <a:solidFill>
+          <a:schemeClr val="phClr"/>
+        </a:solidFill>
+        <a:gradFill rotWithShape="1">
+          <a:gsLst>
+            <a:gs pos="0">
+              <a:schemeClr val="phClr">
+                <a:tint val="50000"/>
+                <a:satMod val="300000"/>
+              </a:schemeClr>
+            </a:gs>
+            <a:gs pos="35000">
+              <a:schemeClr val="phClr">
+                <a:tint val="37000"/>
+                <a:satMod val="300000"/>
+              </a:schemeClr>
+            </a:gs>
+            <a:gs pos="100000">
+              <a:schemeClr val="phClr">
+                <a:tint val="15000"/>
+                <a:satMod val="350000"/>
+              </a:schemeClr>
+            </a:gs>
+          </a:gsLst>
+          <a:lin ang="16200000" scaled="1"/>
+        </a:gradFill>
+        <a:gradFill rotWithShape="1">
+          <a:gsLst>
+            <a:gs pos="0">
+              <a:schemeClr val="phClr">
+                <a:tint val="100000"/>
+                <a:shade val="100000"/>
+                <a:satMod val="130000"/>
+              </a:schemeClr>
+            </a:gs>
+            <a:gs pos="100000">
+              <a:schemeClr val="phClr">
+                <a:tint val="50000"/>
+                <a:shade val="100000"/>
+                <a:satMod val="350000"/>
+              </a:schemeClr>
+            </a:gs>
+          </a:gsLst>
+          <a:lin ang="16200000" scaled="0"/>
+        </a:gradFill>
+      </a:fillStyleLst>
+      <a:lnStyleLst>
+        <a:ln w="9525" cap="flat" cmpd="sng" algn="ctr">
+          <a:solidFill>
+            <a:schemeClr val="phClr">
+              <a:shade val="95000"/>
+              <a:satMod val="105000"/>
+            </a:schemeClr>
+          </a:solidFill>
+          <a:prstDash val="solid"/>
+        </a:ln>
+        <a:ln w="25400" cap="flat" cmpd="sng" algn="ctr">
+          <a:solidFill>
+            <a:schemeClr val="phClr"/>
+          </a:solidFill>
+          <a:prstDash val="solid"/>
+        </a:ln>
+        <a:ln w="38100" cap="flat" cmpd="sng" algn="ctr">
+          <a:solidFill>
+            <a:schemeClr val="phClr"/>
+          </a:solidFill>
+          <a:prstDash val="solid"/>
+        </a:ln>
+      </a:lnStyleLst>
+      <a:effectStyleLst>
+        <a:effectStyle>
+          <a:effectLst>
+            <a:outerShdw blurRad="40000" dist="20000" dir="5400000" rotWithShape="0">
+              <a:srgbClr val="000000">
+                <a:alpha val="38000"/>
+              </a:srgbClr>
+            </a:outerShdw>
+          </a:effectLst>
+        </a:effectStyle>
+        <a:effectStyle>
+          <a:effectLst>
+            <a:outerShdw blurRad="40000" dist="23000" dir="5400000" rotWithShape="0">
+              <a:srgbClr val="000000">
+                <a:alpha val="35000"/>
+              </a:srgbClr>
+            </a:outerShdw>
+          </a:effectLst>
+        </a:effectStyle>
+        <a:effectStyle>
+          <a:effectLst>
+            <a:outerShdw blurRad="40000" dist="23000" dir="5400000" rotWithShape="0">
+              <a:srgbClr val="000000">
+                <a:alpha val="35000"/>
+              </a:srgbClr>
+            </a:outerShdw>
+          </a:effectLst>
+          <a:scene3d>
+            <a:camera prst="orthographicFront">
+              <a:rot lat="0" lon="0" rev="0"/>
+            </a:camera>
+            <a:lightRig rig="threePt" dir="t">
+              <a:rot lat="0" lon="0" rev="1200000"/>
+            </a:lightRig>
+          </a:scene3d>
+          <a:sp3d>
+            <a:bevelT w="63500" h="25400"/>
+          </a:sp3d>
+        </a:effectStyle>
+      </a:effectStyleLst>
+      <a:bgFillStyleLst>
+        <a:solidFill>
+          <a:schemeClr val="phClr"/>
+        </a:solidFill>
+        <a:gradFill rotWithShape="1">
+          <a:gsLst>
+            <a:gs pos="0">
+              <a:schemeClr val="phClr">
+                <a:tint val="40000"/>
+                <a:satMod val="350000"/>
+              </a:schemeClr>
+            </a:gs>
+            <a:gs pos="40000">
+              <a:schemeClr val="phClr">
+                <a:tint val="45000"/>
+                <a:shade val="99000"/>
+                <a:satMod val="350000"/>
+              </a:schemeClr>
+            </a:gs>
+            <a:gs pos="100000">
+              <a:schemeClr val="phClr">
+                <a:shade val="20000"/>
+                <a:satMod val="255000"/>
+              </a:schemeClr>
+            </a:gs>
+          </a:gsLst>
+          <a:path path="circle">
+            <a:fillToRect l="50000" t="-80000" r="50000" b="180000"/>
+          </a:path>
+        </a:gradFill>
+        <a:gradFill rotWithShape="1">
+          <a:gsLst>
+            <a:gs pos="0">
+              <a:schemeClr val="phClr">
+                <a:tint val="80000"/>
+                <a:satMod val="300000"/>
+              </a:schemeClr>
+            </a:gs>
+            <a:gs pos="100000">
+              <a:schemeClr val="phClr">
+                <a:shade val="30000"/>
+                <a:satMod val="200000"/>
+              </a:schemeClr>
+            </a:gs>
+          </a:gsLst>
+          <a:path path="circle">
+            <a:fillToRect l="50000" t="50000" r="50000" b="50000"/>
+          </a:path>
+        </a:gradFill>
+      </a:bgFillStyleLst>
+    </a:fmtScheme>
+  </a:themeElements>
+</a:theme>
+</file>
+
+<file path=ppt/theme/theme2.xml><?xml version="1.0" encoding="utf-8"?>
 <a:theme xmlns:a="http://schemas.openxmlformats.org/drawingml/2006/main" xmlns:r="http://schemas.openxmlformats.org/officeDocument/2006/relationships" name="Default Design">
   <a:themeElements>
     <a:clrScheme name="Custom 1">
@@ -16008,283 +16341,4 @@
     </a:fmtScheme>
   </a:themeElements>
 </a:theme>
-</file>
-
-<file path=ppt/theme/theme2.xml><?xml version="1.0" encoding="utf-8"?>
-<a:theme xmlns:a="http://schemas.openxmlformats.org/drawingml/2006/main" xmlns:r="http://schemas.openxmlformats.org/officeDocument/2006/relationships">
-  <a:themeElements>
-    <a:clrScheme name="Default">
-      <a:dk1>
-        <a:srgbClr val="000000"/>
-      </a:dk1>
-      <a:lt1>
-        <a:srgbClr val="FFFFFF"/>
-      </a:lt1>
-      <a:dk2>
-        <a:srgbClr val="158158"/>
-      </a:dk2>
-      <a:lt2>
-        <a:srgbClr val="F3F3F3"/>
-      </a:lt2>
-      <a:accent1>
-        <a:srgbClr val="058DC7"/>
-      </a:accent1>
-      <a:accent2>
-        <a:srgbClr val="50B432"/>
-      </a:accent2>
-      <a:accent3>
-        <a:srgbClr val="ED561B"/>
-      </a:accent3>
-      <a:accent4>
-        <a:srgbClr val="EDEF00"/>
-      </a:accent4>
-      <a:accent5>
-        <a:srgbClr val="24CBE5"/>
-      </a:accent5>
-      <a:accent6>
-        <a:srgbClr val="64E572"/>
-      </a:accent6>
-      <a:hlink>
-        <a:srgbClr val="2200CC"/>
-      </a:hlink>
-      <a:folHlink>
-        <a:srgbClr val="551A8B"/>
-      </a:folHlink>
-    </a:clrScheme>
-    <a:fontScheme name="Office">
-      <a:majorFont>
-        <a:latin typeface="Arial"/>
-        <a:ea typeface=""/>
-        <a:cs typeface=""/>
-        <a:font script="Jpan" typeface="ＭＳ Ｐゴシック"/>
-        <a:font script="Hang" typeface="맑은 고딕"/>
-        <a:font script="Hans" typeface="宋体"/>
-        <a:font script="Hant" typeface="新細明體"/>
-        <a:font script="Arab" typeface="Times New Roman"/>
-        <a:font script="Hebr" typeface="Times New Roman"/>
-        <a:font script="Thai" typeface="Angsana New"/>
-        <a:font script="Ethi" typeface="Nyala"/>
-        <a:font script="Beng" typeface="Vrinda"/>
-        <a:font script="Gujr" typeface="Shruti"/>
-        <a:font script="Khmr" typeface="MoolBoran"/>
-        <a:font script="Knda" typeface="Tunga"/>
-        <a:font script="Guru" typeface="Raavi"/>
-        <a:font script="Cans" typeface="Euphemia"/>
-        <a:font script="Cher" typeface="Plantagenet Cherokee"/>
-        <a:font script="Yiii" typeface="Microsoft Yi Baiti"/>
-        <a:font script="Tibt" typeface="Microsoft Himalaya"/>
-        <a:font script="Thaa" typeface="MV Boli"/>
-        <a:font script="Deva" typeface="Mangal"/>
-        <a:font script="Telu" typeface="Gautami"/>
-        <a:font script="Taml" typeface="Latha"/>
-        <a:font script="Syrc" typeface="Estrangelo Edessa"/>
-        <a:font script="Orya" typeface="Kalinga"/>
-        <a:font script="Mlym" typeface="Kartika"/>
-        <a:font script="Laoo" typeface="DokChampa"/>
-        <a:font script="Sinh" typeface="Iskoola Pota"/>
-        <a:font script="Mong" typeface="Mongolian Baiti"/>
-        <a:font script="Viet" typeface="Times New Roman"/>
-        <a:font script="Uigh" typeface="Microsoft Uighur"/>
-        <a:font script="Geor" typeface="Sylfaen"/>
-      </a:majorFont>
-      <a:minorFont>
-        <a:latin typeface="Arial"/>
-        <a:ea typeface=""/>
-        <a:cs typeface=""/>
-        <a:font script="Jpan" typeface="ＭＳ Ｐゴシック"/>
-        <a:font script="Hang" typeface="맑은 고딕"/>
-        <a:font script="Hans" typeface="宋体"/>
-        <a:font script="Hant" typeface="新細明體"/>
-        <a:font script="Arab" typeface="Arial"/>
-        <a:font script="Hebr" typeface="Arial"/>
-        <a:font script="Thai" typeface="Cordia New"/>
-        <a:font script="Ethi" typeface="Nyala"/>
-        <a:font script="Beng" typeface="Vrinda"/>
-        <a:font script="Gujr" typeface="Shruti"/>
-        <a:font script="Khmr" typeface="DaunPenh"/>
-        <a:font script="Knda" typeface="Tunga"/>
-        <a:font script="Guru" typeface="Raavi"/>
-        <a:font script="Cans" typeface="Euphemia"/>
-        <a:font script="Cher" typeface="Plantagenet Cherokee"/>
-        <a:font script="Yiii" typeface="Microsoft Yi Baiti"/>
-        <a:font script="Tibt" typeface="Microsoft Himalaya"/>
-        <a:font script="Thaa" typeface="MV Boli"/>
-        <a:font script="Deva" typeface="Mangal"/>
-        <a:font script="Telu" typeface="Gautami"/>
-        <a:font script="Taml" typeface="Latha"/>
-        <a:font script="Syrc" typeface="Estrangelo Edessa"/>
-        <a:font script="Orya" typeface="Kalinga"/>
-        <a:font script="Mlym" typeface="Kartika"/>
-        <a:font script="Laoo" typeface="DokChampa"/>
-        <a:font script="Sinh" typeface="Iskoola Pota"/>
-        <a:font script="Mong" typeface="Mongolian Baiti"/>
-        <a:font script="Viet" typeface="Arial"/>
-        <a:font script="Uigh" typeface="Microsoft Uighur"/>
-        <a:font script="Geor" typeface="Sylfaen"/>
-      </a:minorFont>
-    </a:fontScheme>
-    <a:fmtScheme name="Office">
-      <a:fillStyleLst>
-        <a:solidFill>
-          <a:schemeClr val="phClr"/>
-        </a:solidFill>
-        <a:gradFill rotWithShape="1">
-          <a:gsLst>
-            <a:gs pos="0">
-              <a:schemeClr val="phClr">
-                <a:tint val="50000"/>
-                <a:satMod val="300000"/>
-              </a:schemeClr>
-            </a:gs>
-            <a:gs pos="35000">
-              <a:schemeClr val="phClr">
-                <a:tint val="37000"/>
-                <a:satMod val="300000"/>
-              </a:schemeClr>
-            </a:gs>
-            <a:gs pos="100000">
-              <a:schemeClr val="phClr">
-                <a:tint val="15000"/>
-                <a:satMod val="350000"/>
-              </a:schemeClr>
-            </a:gs>
-          </a:gsLst>
-          <a:lin ang="16200000" scaled="1"/>
-        </a:gradFill>
-        <a:gradFill rotWithShape="1">
-          <a:gsLst>
-            <a:gs pos="0">
-              <a:schemeClr val="phClr">
-                <a:tint val="100000"/>
-                <a:shade val="100000"/>
-                <a:satMod val="130000"/>
-              </a:schemeClr>
-            </a:gs>
-            <a:gs pos="100000">
-              <a:schemeClr val="phClr">
-                <a:tint val="50000"/>
-                <a:shade val="100000"/>
-                <a:satMod val="350000"/>
-              </a:schemeClr>
-            </a:gs>
-          </a:gsLst>
-          <a:lin ang="16200000" scaled="0"/>
-        </a:gradFill>
-      </a:fillStyleLst>
-      <a:lnStyleLst>
-        <a:ln w="9525" cap="flat" cmpd="sng" algn="ctr">
-          <a:solidFill>
-            <a:schemeClr val="phClr">
-              <a:shade val="95000"/>
-              <a:satMod val="105000"/>
-            </a:schemeClr>
-          </a:solidFill>
-          <a:prstDash val="solid"/>
-        </a:ln>
-        <a:ln w="25400" cap="flat" cmpd="sng" algn="ctr">
-          <a:solidFill>
-            <a:schemeClr val="phClr"/>
-          </a:solidFill>
-          <a:prstDash val="solid"/>
-        </a:ln>
-        <a:ln w="38100" cap="flat" cmpd="sng" algn="ctr">
-          <a:solidFill>
-            <a:schemeClr val="phClr"/>
-          </a:solidFill>
-          <a:prstDash val="solid"/>
-        </a:ln>
-      </a:lnStyleLst>
-      <a:effectStyleLst>
-        <a:effectStyle>
-          <a:effectLst>
-            <a:outerShdw blurRad="40000" dist="20000" dir="5400000" rotWithShape="0">
-              <a:srgbClr val="000000">
-                <a:alpha val="38000"/>
-              </a:srgbClr>
-            </a:outerShdw>
-          </a:effectLst>
-        </a:effectStyle>
-        <a:effectStyle>
-          <a:effectLst>
-            <a:outerShdw blurRad="40000" dist="23000" dir="5400000" rotWithShape="0">
-              <a:srgbClr val="000000">
-                <a:alpha val="35000"/>
-              </a:srgbClr>
-            </a:outerShdw>
-          </a:effectLst>
-        </a:effectStyle>
-        <a:effectStyle>
-          <a:effectLst>
-            <a:outerShdw blurRad="40000" dist="23000" dir="5400000" rotWithShape="0">
-              <a:srgbClr val="000000">
-                <a:alpha val="35000"/>
-              </a:srgbClr>
-            </a:outerShdw>
-          </a:effectLst>
-          <a:scene3d>
-            <a:camera prst="orthographicFront">
-              <a:rot lat="0" lon="0" rev="0"/>
-            </a:camera>
-            <a:lightRig rig="threePt" dir="t">
-              <a:rot lat="0" lon="0" rev="1200000"/>
-            </a:lightRig>
-          </a:scene3d>
-          <a:sp3d>
-            <a:bevelT w="63500" h="25400"/>
-          </a:sp3d>
-        </a:effectStyle>
-      </a:effectStyleLst>
-      <a:bgFillStyleLst>
-        <a:solidFill>
-          <a:schemeClr val="phClr"/>
-        </a:solidFill>
-        <a:gradFill rotWithShape="1">
-          <a:gsLst>
-            <a:gs pos="0">
-              <a:schemeClr val="phClr">
-                <a:tint val="40000"/>
-                <a:satMod val="350000"/>
-              </a:schemeClr>
-            </a:gs>
-            <a:gs pos="40000">
-              <a:schemeClr val="phClr">
-                <a:tint val="45000"/>
-                <a:shade val="99000"/>
-                <a:satMod val="350000"/>
-              </a:schemeClr>
-            </a:gs>
-            <a:gs pos="100000">
-              <a:schemeClr val="phClr">
-                <a:shade val="20000"/>
-                <a:satMod val="255000"/>
-              </a:schemeClr>
-            </a:gs>
-          </a:gsLst>
-          <a:path path="circle">
-            <a:fillToRect l="50000" t="-80000" r="50000" b="180000"/>
-          </a:path>
-        </a:gradFill>
-        <a:gradFill rotWithShape="1">
-          <a:gsLst>
-            <a:gs pos="0">
-              <a:schemeClr val="phClr">
-                <a:tint val="80000"/>
-                <a:satMod val="300000"/>
-              </a:schemeClr>
-            </a:gs>
-            <a:gs pos="100000">
-              <a:schemeClr val="phClr">
-                <a:shade val="30000"/>
-                <a:satMod val="200000"/>
-              </a:schemeClr>
-            </a:gs>
-          </a:gsLst>
-          <a:path path="circle">
-            <a:fillToRect l="50000" t="50000" r="50000" b="50000"/>
-          </a:path>
-        </a:gradFill>
-      </a:bgFillStyleLst>
-    </a:fmtScheme>
-  </a:themeElements>
-</a:theme>
 </file>
</xml_diff>

<commit_message>
Real-world use case and its impact
</commit_message>
<xml_diff>
--- a/2023263 AI CA1.pptx
+++ b/2023263 AI CA1.pptx
@@ -14610,7 +14610,7 @@
         </p:nvSpPr>
         <p:spPr>
           <a:xfrm>
-            <a:off x="15073313" y="26417975"/>
+            <a:off x="15101538" y="28348188"/>
             <a:ext cx="12787200" cy="461700"/>
           </a:xfrm>
           <a:prstGeom prst="rect">
@@ -14732,7 +14732,7 @@
         </p:nvSpPr>
         <p:spPr>
           <a:xfrm>
-            <a:off x="15154275" y="18266162"/>
+            <a:off x="15182500" y="20196375"/>
             <a:ext cx="12660300" cy="8045400"/>
           </a:xfrm>
           <a:prstGeom prst="rect">
@@ -15023,9 +15023,9 @@
         <p:grpSpPr>
           <a:xfrm>
             <a:off x="15033717" y="11476908"/>
-            <a:ext cx="12885811" cy="1108011"/>
+            <a:ext cx="12885811" cy="2124212"/>
             <a:chOff x="14894284" y="5068979"/>
-            <a:chExt cx="12887100" cy="1107900"/>
+            <a:chExt cx="12887100" cy="2124000"/>
           </a:xfrm>
         </p:grpSpPr>
         <p:sp>
@@ -15037,7 +15037,7 @@
           <p:spPr>
             <a:xfrm>
               <a:off x="14894284" y="5068979"/>
-              <a:ext cx="12887100" cy="1107900"/>
+              <a:ext cx="12887100" cy="2124000"/>
             </a:xfrm>
             <a:prstGeom prst="rect">
               <a:avLst/>
@@ -15071,16 +15071,12 @@
                 <a:buNone/>
               </a:pPr>
               <a:r>
-                <a:rPr b="1" i="0" lang="en-US" sz="6600" u="none">
+                <a:rPr b="1" lang="en-US" sz="6600">
                   <a:solidFill>
                     <a:srgbClr val="006684"/>
                   </a:solidFill>
-                  <a:latin typeface="Arial"/>
-                  <a:ea typeface="Arial"/>
-                  <a:cs typeface="Arial"/>
-                  <a:sym typeface="Arial"/>
                 </a:rPr>
-                <a:t>Results</a:t>
+                <a:t>Real-world use case of deepfake and its impact</a:t>
               </a:r>
               <a:endParaRPr/>
             </a:p>
@@ -15414,8 +15410,8 @@
         </p:nvSpPr>
         <p:spPr>
           <a:xfrm>
-            <a:off x="15016163" y="12656275"/>
-            <a:ext cx="12936600" cy="646500"/>
+            <a:off x="15016163" y="13673450"/>
+            <a:ext cx="12936600" cy="6033900"/>
           </a:xfrm>
           <a:prstGeom prst="rect">
             <a:avLst/>
@@ -15449,7 +15445,7 @@
               <a:buNone/>
             </a:pPr>
             <a:r>
-              <a:rPr b="0" i="0" lang="en-US" sz="3600" u="none">
+              <a:rPr lang="en-US" sz="3600">
                 <a:solidFill>
                   <a:schemeClr val="dk1"/>
                 </a:solidFill>
@@ -15458,7 +15454,7 @@
                 <a:cs typeface="Helvetica Neue"/>
                 <a:sym typeface="Helvetica Neue"/>
               </a:rPr>
-              <a:t>Text size 36pt Arial and exactly 50pt space between lines</a:t>
+              <a:t>A finance employee of a Hong Kong company joined a video conference meeting with who appeared to be the company’s chief financial officer and colleagues while being asked to realise a secret transfer, he agreed to transfer the amount of 200 million Hong Kong dollars(around $25 million), due to seeing his colleagues and chief on the meeting, learning later on that everyone he saw on the meeting besides him were fake.(Chen and Magramo, 2024)</a:t>
             </a:r>
             <a:endParaRPr/>
           </a:p>
@@ -15786,6 +15782,285 @@
 </file>
 
 <file path=ppt/theme/theme1.xml><?xml version="1.0" encoding="utf-8"?>
+<a:theme xmlns:a="http://schemas.openxmlformats.org/drawingml/2006/main" xmlns:r="http://schemas.openxmlformats.org/officeDocument/2006/relationships" name="Default Design">
+  <a:themeElements>
+    <a:clrScheme name="Custom 1">
+      <a:dk1>
+        <a:srgbClr val="000000"/>
+      </a:dk1>
+      <a:lt1>
+        <a:srgbClr val="FFFFFF"/>
+      </a:lt1>
+      <a:dk2>
+        <a:srgbClr val="000000"/>
+      </a:dk2>
+      <a:lt2>
+        <a:srgbClr val="808080"/>
+      </a:lt2>
+      <a:accent1>
+        <a:srgbClr val="D11242"/>
+      </a:accent1>
+      <a:accent2>
+        <a:srgbClr val="3333CC"/>
+      </a:accent2>
+      <a:accent3>
+        <a:srgbClr val="FFFFFF"/>
+      </a:accent3>
+      <a:accent4>
+        <a:srgbClr val="000000"/>
+      </a:accent4>
+      <a:accent5>
+        <a:srgbClr val="AAE2CA"/>
+      </a:accent5>
+      <a:accent6>
+        <a:srgbClr val="2D2DB9"/>
+      </a:accent6>
+      <a:hlink>
+        <a:srgbClr val="CCCCFF"/>
+      </a:hlink>
+      <a:folHlink>
+        <a:srgbClr val="B2B2B2"/>
+      </a:folHlink>
+    </a:clrScheme>
+    <a:fontScheme name="Office">
+      <a:majorFont>
+        <a:latin typeface="Arial"/>
+        <a:ea typeface=""/>
+        <a:cs typeface=""/>
+        <a:font script="Jpan" typeface="ＭＳ Ｐゴシック"/>
+        <a:font script="Hang" typeface="맑은 고딕"/>
+        <a:font script="Hans" typeface="宋体"/>
+        <a:font script="Hant" typeface="新細明體"/>
+        <a:font script="Arab" typeface="Times New Roman"/>
+        <a:font script="Hebr" typeface="Times New Roman"/>
+        <a:font script="Thai" typeface="Angsana New"/>
+        <a:font script="Ethi" typeface="Nyala"/>
+        <a:font script="Beng" typeface="Vrinda"/>
+        <a:font script="Gujr" typeface="Shruti"/>
+        <a:font script="Khmr" typeface="MoolBoran"/>
+        <a:font script="Knda" typeface="Tunga"/>
+        <a:font script="Guru" typeface="Raavi"/>
+        <a:font script="Cans" typeface="Euphemia"/>
+        <a:font script="Cher" typeface="Plantagenet Cherokee"/>
+        <a:font script="Yiii" typeface="Microsoft Yi Baiti"/>
+        <a:font script="Tibt" typeface="Microsoft Himalaya"/>
+        <a:font script="Thaa" typeface="MV Boli"/>
+        <a:font script="Deva" typeface="Mangal"/>
+        <a:font script="Telu" typeface="Gautami"/>
+        <a:font script="Taml" typeface="Latha"/>
+        <a:font script="Syrc" typeface="Estrangelo Edessa"/>
+        <a:font script="Orya" typeface="Kalinga"/>
+        <a:font script="Mlym" typeface="Kartika"/>
+        <a:font script="Laoo" typeface="DokChampa"/>
+        <a:font script="Sinh" typeface="Iskoola Pota"/>
+        <a:font script="Mong" typeface="Mongolian Baiti"/>
+        <a:font script="Viet" typeface="Times New Roman"/>
+        <a:font script="Uigh" typeface="Microsoft Uighur"/>
+        <a:font script="Geor" typeface="Sylfaen"/>
+      </a:majorFont>
+      <a:minorFont>
+        <a:latin typeface="Arial"/>
+        <a:ea typeface=""/>
+        <a:cs typeface=""/>
+        <a:font script="Jpan" typeface="ＭＳ Ｐゴシック"/>
+        <a:font script="Hang" typeface="맑은 고딕"/>
+        <a:font script="Hans" typeface="宋体"/>
+        <a:font script="Hant" typeface="新細明體"/>
+        <a:font script="Arab" typeface="Arial"/>
+        <a:font script="Hebr" typeface="Arial"/>
+        <a:font script="Thai" typeface="Cordia New"/>
+        <a:font script="Ethi" typeface="Nyala"/>
+        <a:font script="Beng" typeface="Vrinda"/>
+        <a:font script="Gujr" typeface="Shruti"/>
+        <a:font script="Khmr" typeface="DaunPenh"/>
+        <a:font script="Knda" typeface="Tunga"/>
+        <a:font script="Guru" typeface="Raavi"/>
+        <a:font script="Cans" typeface="Euphemia"/>
+        <a:font script="Cher" typeface="Plantagenet Cherokee"/>
+        <a:font script="Yiii" typeface="Microsoft Yi Baiti"/>
+        <a:font script="Tibt" typeface="Microsoft Himalaya"/>
+        <a:font script="Thaa" typeface="MV Boli"/>
+        <a:font script="Deva" typeface="Mangal"/>
+        <a:font script="Telu" typeface="Gautami"/>
+        <a:font script="Taml" typeface="Latha"/>
+        <a:font script="Syrc" typeface="Estrangelo Edessa"/>
+        <a:font script="Orya" typeface="Kalinga"/>
+        <a:font script="Mlym" typeface="Kartika"/>
+        <a:font script="Laoo" typeface="DokChampa"/>
+        <a:font script="Sinh" typeface="Iskoola Pota"/>
+        <a:font script="Mong" typeface="Mongolian Baiti"/>
+        <a:font script="Viet" typeface="Arial"/>
+        <a:font script="Uigh" typeface="Microsoft Uighur"/>
+        <a:font script="Geor" typeface="Sylfaen"/>
+      </a:minorFont>
+    </a:fontScheme>
+    <a:fmtScheme name="Office">
+      <a:fillStyleLst>
+        <a:solidFill>
+          <a:schemeClr val="phClr"/>
+        </a:solidFill>
+        <a:gradFill rotWithShape="1">
+          <a:gsLst>
+            <a:gs pos="0">
+              <a:schemeClr val="phClr">
+                <a:tint val="50000"/>
+                <a:satMod val="300000"/>
+              </a:schemeClr>
+            </a:gs>
+            <a:gs pos="35000">
+              <a:schemeClr val="phClr">
+                <a:tint val="37000"/>
+                <a:satMod val="300000"/>
+              </a:schemeClr>
+            </a:gs>
+            <a:gs pos="100000">
+              <a:schemeClr val="phClr">
+                <a:tint val="15000"/>
+                <a:satMod val="350000"/>
+              </a:schemeClr>
+            </a:gs>
+          </a:gsLst>
+          <a:lin ang="16200000" scaled="1"/>
+        </a:gradFill>
+        <a:gradFill rotWithShape="1">
+          <a:gsLst>
+            <a:gs pos="0">
+              <a:schemeClr val="phClr">
+                <a:tint val="100000"/>
+                <a:shade val="100000"/>
+                <a:satMod val="130000"/>
+              </a:schemeClr>
+            </a:gs>
+            <a:gs pos="100000">
+              <a:schemeClr val="phClr">
+                <a:tint val="50000"/>
+                <a:shade val="100000"/>
+                <a:satMod val="350000"/>
+              </a:schemeClr>
+            </a:gs>
+          </a:gsLst>
+          <a:lin ang="16200000" scaled="0"/>
+        </a:gradFill>
+      </a:fillStyleLst>
+      <a:lnStyleLst>
+        <a:ln w="9525" cap="flat" cmpd="sng" algn="ctr">
+          <a:solidFill>
+            <a:schemeClr val="phClr">
+              <a:shade val="95000"/>
+              <a:satMod val="105000"/>
+            </a:schemeClr>
+          </a:solidFill>
+          <a:prstDash val="solid"/>
+        </a:ln>
+        <a:ln w="25400" cap="flat" cmpd="sng" algn="ctr">
+          <a:solidFill>
+            <a:schemeClr val="phClr"/>
+          </a:solidFill>
+          <a:prstDash val="solid"/>
+        </a:ln>
+        <a:ln w="38100" cap="flat" cmpd="sng" algn="ctr">
+          <a:solidFill>
+            <a:schemeClr val="phClr"/>
+          </a:solidFill>
+          <a:prstDash val="solid"/>
+        </a:ln>
+      </a:lnStyleLst>
+      <a:effectStyleLst>
+        <a:effectStyle>
+          <a:effectLst>
+            <a:outerShdw blurRad="40000" dist="20000" dir="5400000" rotWithShape="0">
+              <a:srgbClr val="000000">
+                <a:alpha val="38000"/>
+              </a:srgbClr>
+            </a:outerShdw>
+          </a:effectLst>
+        </a:effectStyle>
+        <a:effectStyle>
+          <a:effectLst>
+            <a:outerShdw blurRad="40000" dist="23000" dir="5400000" rotWithShape="0">
+              <a:srgbClr val="000000">
+                <a:alpha val="35000"/>
+              </a:srgbClr>
+            </a:outerShdw>
+          </a:effectLst>
+        </a:effectStyle>
+        <a:effectStyle>
+          <a:effectLst>
+            <a:outerShdw blurRad="40000" dist="23000" dir="5400000" rotWithShape="0">
+              <a:srgbClr val="000000">
+                <a:alpha val="35000"/>
+              </a:srgbClr>
+            </a:outerShdw>
+          </a:effectLst>
+          <a:scene3d>
+            <a:camera prst="orthographicFront">
+              <a:rot lat="0" lon="0" rev="0"/>
+            </a:camera>
+            <a:lightRig rig="threePt" dir="t">
+              <a:rot lat="0" lon="0" rev="1200000"/>
+            </a:lightRig>
+          </a:scene3d>
+          <a:sp3d>
+            <a:bevelT w="63500" h="25400"/>
+          </a:sp3d>
+        </a:effectStyle>
+      </a:effectStyleLst>
+      <a:bgFillStyleLst>
+        <a:solidFill>
+          <a:schemeClr val="phClr"/>
+        </a:solidFill>
+        <a:gradFill rotWithShape="1">
+          <a:gsLst>
+            <a:gs pos="0">
+              <a:schemeClr val="phClr">
+                <a:tint val="40000"/>
+                <a:satMod val="350000"/>
+              </a:schemeClr>
+            </a:gs>
+            <a:gs pos="40000">
+              <a:schemeClr val="phClr">
+                <a:tint val="45000"/>
+                <a:shade val="99000"/>
+                <a:satMod val="350000"/>
+              </a:schemeClr>
+            </a:gs>
+            <a:gs pos="100000">
+              <a:schemeClr val="phClr">
+                <a:shade val="20000"/>
+                <a:satMod val="255000"/>
+              </a:schemeClr>
+            </a:gs>
+          </a:gsLst>
+          <a:path path="circle">
+            <a:fillToRect l="50000" t="-80000" r="50000" b="180000"/>
+          </a:path>
+        </a:gradFill>
+        <a:gradFill rotWithShape="1">
+          <a:gsLst>
+            <a:gs pos="0">
+              <a:schemeClr val="phClr">
+                <a:tint val="80000"/>
+                <a:satMod val="300000"/>
+              </a:schemeClr>
+            </a:gs>
+            <a:gs pos="100000">
+              <a:schemeClr val="phClr">
+                <a:shade val="30000"/>
+                <a:satMod val="200000"/>
+              </a:schemeClr>
+            </a:gs>
+          </a:gsLst>
+          <a:path path="circle">
+            <a:fillToRect l="50000" t="50000" r="50000" b="50000"/>
+          </a:path>
+        </a:gradFill>
+      </a:bgFillStyleLst>
+    </a:fmtScheme>
+  </a:themeElements>
+</a:theme>
+</file>
+
+<file path=ppt/theme/theme2.xml><?xml version="1.0" encoding="utf-8"?>
 <a:theme xmlns:a="http://schemas.openxmlformats.org/drawingml/2006/main" xmlns:r="http://schemas.openxmlformats.org/officeDocument/2006/relationships">
   <a:themeElements>
     <a:clrScheme name="Default">
@@ -16062,283 +16337,4 @@
     </a:fmtScheme>
   </a:themeElements>
 </a:theme>
-</file>
-
-<file path=ppt/theme/theme2.xml><?xml version="1.0" encoding="utf-8"?>
-<a:theme xmlns:a="http://schemas.openxmlformats.org/drawingml/2006/main" xmlns:r="http://schemas.openxmlformats.org/officeDocument/2006/relationships" name="Default Design">
-  <a:themeElements>
-    <a:clrScheme name="Custom 1">
-      <a:dk1>
-        <a:srgbClr val="000000"/>
-      </a:dk1>
-      <a:lt1>
-        <a:srgbClr val="FFFFFF"/>
-      </a:lt1>
-      <a:dk2>
-        <a:srgbClr val="000000"/>
-      </a:dk2>
-      <a:lt2>
-        <a:srgbClr val="808080"/>
-      </a:lt2>
-      <a:accent1>
-        <a:srgbClr val="D11242"/>
-      </a:accent1>
-      <a:accent2>
-        <a:srgbClr val="3333CC"/>
-      </a:accent2>
-      <a:accent3>
-        <a:srgbClr val="FFFFFF"/>
-      </a:accent3>
-      <a:accent4>
-        <a:srgbClr val="000000"/>
-      </a:accent4>
-      <a:accent5>
-        <a:srgbClr val="AAE2CA"/>
-      </a:accent5>
-      <a:accent6>
-        <a:srgbClr val="2D2DB9"/>
-      </a:accent6>
-      <a:hlink>
-        <a:srgbClr val="CCCCFF"/>
-      </a:hlink>
-      <a:folHlink>
-        <a:srgbClr val="B2B2B2"/>
-      </a:folHlink>
-    </a:clrScheme>
-    <a:fontScheme name="Office">
-      <a:majorFont>
-        <a:latin typeface="Arial"/>
-        <a:ea typeface=""/>
-        <a:cs typeface=""/>
-        <a:font script="Jpan" typeface="ＭＳ Ｐゴシック"/>
-        <a:font script="Hang" typeface="맑은 고딕"/>
-        <a:font script="Hans" typeface="宋体"/>
-        <a:font script="Hant" typeface="新細明體"/>
-        <a:font script="Arab" typeface="Times New Roman"/>
-        <a:font script="Hebr" typeface="Times New Roman"/>
-        <a:font script="Thai" typeface="Angsana New"/>
-        <a:font script="Ethi" typeface="Nyala"/>
-        <a:font script="Beng" typeface="Vrinda"/>
-        <a:font script="Gujr" typeface="Shruti"/>
-        <a:font script="Khmr" typeface="MoolBoran"/>
-        <a:font script="Knda" typeface="Tunga"/>
-        <a:font script="Guru" typeface="Raavi"/>
-        <a:font script="Cans" typeface="Euphemia"/>
-        <a:font script="Cher" typeface="Plantagenet Cherokee"/>
-        <a:font script="Yiii" typeface="Microsoft Yi Baiti"/>
-        <a:font script="Tibt" typeface="Microsoft Himalaya"/>
-        <a:font script="Thaa" typeface="MV Boli"/>
-        <a:font script="Deva" typeface="Mangal"/>
-        <a:font script="Telu" typeface="Gautami"/>
-        <a:font script="Taml" typeface="Latha"/>
-        <a:font script="Syrc" typeface="Estrangelo Edessa"/>
-        <a:font script="Orya" typeface="Kalinga"/>
-        <a:font script="Mlym" typeface="Kartika"/>
-        <a:font script="Laoo" typeface="DokChampa"/>
-        <a:font script="Sinh" typeface="Iskoola Pota"/>
-        <a:font script="Mong" typeface="Mongolian Baiti"/>
-        <a:font script="Viet" typeface="Times New Roman"/>
-        <a:font script="Uigh" typeface="Microsoft Uighur"/>
-        <a:font script="Geor" typeface="Sylfaen"/>
-      </a:majorFont>
-      <a:minorFont>
-        <a:latin typeface="Arial"/>
-        <a:ea typeface=""/>
-        <a:cs typeface=""/>
-        <a:font script="Jpan" typeface="ＭＳ Ｐゴシック"/>
-        <a:font script="Hang" typeface="맑은 고딕"/>
-        <a:font script="Hans" typeface="宋体"/>
-        <a:font script="Hant" typeface="新細明體"/>
-        <a:font script="Arab" typeface="Arial"/>
-        <a:font script="Hebr" typeface="Arial"/>
-        <a:font script="Thai" typeface="Cordia New"/>
-        <a:font script="Ethi" typeface="Nyala"/>
-        <a:font script="Beng" typeface="Vrinda"/>
-        <a:font script="Gujr" typeface="Shruti"/>
-        <a:font script="Khmr" typeface="DaunPenh"/>
-        <a:font script="Knda" typeface="Tunga"/>
-        <a:font script="Guru" typeface="Raavi"/>
-        <a:font script="Cans" typeface="Euphemia"/>
-        <a:font script="Cher" typeface="Plantagenet Cherokee"/>
-        <a:font script="Yiii" typeface="Microsoft Yi Baiti"/>
-        <a:font script="Tibt" typeface="Microsoft Himalaya"/>
-        <a:font script="Thaa" typeface="MV Boli"/>
-        <a:font script="Deva" typeface="Mangal"/>
-        <a:font script="Telu" typeface="Gautami"/>
-        <a:font script="Taml" typeface="Latha"/>
-        <a:font script="Syrc" typeface="Estrangelo Edessa"/>
-        <a:font script="Orya" typeface="Kalinga"/>
-        <a:font script="Mlym" typeface="Kartika"/>
-        <a:font script="Laoo" typeface="DokChampa"/>
-        <a:font script="Sinh" typeface="Iskoola Pota"/>
-        <a:font script="Mong" typeface="Mongolian Baiti"/>
-        <a:font script="Viet" typeface="Arial"/>
-        <a:font script="Uigh" typeface="Microsoft Uighur"/>
-        <a:font script="Geor" typeface="Sylfaen"/>
-      </a:minorFont>
-    </a:fontScheme>
-    <a:fmtScheme name="Office">
-      <a:fillStyleLst>
-        <a:solidFill>
-          <a:schemeClr val="phClr"/>
-        </a:solidFill>
-        <a:gradFill rotWithShape="1">
-          <a:gsLst>
-            <a:gs pos="0">
-              <a:schemeClr val="phClr">
-                <a:tint val="50000"/>
-                <a:satMod val="300000"/>
-              </a:schemeClr>
-            </a:gs>
-            <a:gs pos="35000">
-              <a:schemeClr val="phClr">
-                <a:tint val="37000"/>
-                <a:satMod val="300000"/>
-              </a:schemeClr>
-            </a:gs>
-            <a:gs pos="100000">
-              <a:schemeClr val="phClr">
-                <a:tint val="15000"/>
-                <a:satMod val="350000"/>
-              </a:schemeClr>
-            </a:gs>
-          </a:gsLst>
-          <a:lin ang="16200000" scaled="1"/>
-        </a:gradFill>
-        <a:gradFill rotWithShape="1">
-          <a:gsLst>
-            <a:gs pos="0">
-              <a:schemeClr val="phClr">
-                <a:tint val="100000"/>
-                <a:shade val="100000"/>
-                <a:satMod val="130000"/>
-              </a:schemeClr>
-            </a:gs>
-            <a:gs pos="100000">
-              <a:schemeClr val="phClr">
-                <a:tint val="50000"/>
-                <a:shade val="100000"/>
-                <a:satMod val="350000"/>
-              </a:schemeClr>
-            </a:gs>
-          </a:gsLst>
-          <a:lin ang="16200000" scaled="0"/>
-        </a:gradFill>
-      </a:fillStyleLst>
-      <a:lnStyleLst>
-        <a:ln w="9525" cap="flat" cmpd="sng" algn="ctr">
-          <a:solidFill>
-            <a:schemeClr val="phClr">
-              <a:shade val="95000"/>
-              <a:satMod val="105000"/>
-            </a:schemeClr>
-          </a:solidFill>
-          <a:prstDash val="solid"/>
-        </a:ln>
-        <a:ln w="25400" cap="flat" cmpd="sng" algn="ctr">
-          <a:solidFill>
-            <a:schemeClr val="phClr"/>
-          </a:solidFill>
-          <a:prstDash val="solid"/>
-        </a:ln>
-        <a:ln w="38100" cap="flat" cmpd="sng" algn="ctr">
-          <a:solidFill>
-            <a:schemeClr val="phClr"/>
-          </a:solidFill>
-          <a:prstDash val="solid"/>
-        </a:ln>
-      </a:lnStyleLst>
-      <a:effectStyleLst>
-        <a:effectStyle>
-          <a:effectLst>
-            <a:outerShdw blurRad="40000" dist="20000" dir="5400000" rotWithShape="0">
-              <a:srgbClr val="000000">
-                <a:alpha val="38000"/>
-              </a:srgbClr>
-            </a:outerShdw>
-          </a:effectLst>
-        </a:effectStyle>
-        <a:effectStyle>
-          <a:effectLst>
-            <a:outerShdw blurRad="40000" dist="23000" dir="5400000" rotWithShape="0">
-              <a:srgbClr val="000000">
-                <a:alpha val="35000"/>
-              </a:srgbClr>
-            </a:outerShdw>
-          </a:effectLst>
-        </a:effectStyle>
-        <a:effectStyle>
-          <a:effectLst>
-            <a:outerShdw blurRad="40000" dist="23000" dir="5400000" rotWithShape="0">
-              <a:srgbClr val="000000">
-                <a:alpha val="35000"/>
-              </a:srgbClr>
-            </a:outerShdw>
-          </a:effectLst>
-          <a:scene3d>
-            <a:camera prst="orthographicFront">
-              <a:rot lat="0" lon="0" rev="0"/>
-            </a:camera>
-            <a:lightRig rig="threePt" dir="t">
-              <a:rot lat="0" lon="0" rev="1200000"/>
-            </a:lightRig>
-          </a:scene3d>
-          <a:sp3d>
-            <a:bevelT w="63500" h="25400"/>
-          </a:sp3d>
-        </a:effectStyle>
-      </a:effectStyleLst>
-      <a:bgFillStyleLst>
-        <a:solidFill>
-          <a:schemeClr val="phClr"/>
-        </a:solidFill>
-        <a:gradFill rotWithShape="1">
-          <a:gsLst>
-            <a:gs pos="0">
-              <a:schemeClr val="phClr">
-                <a:tint val="40000"/>
-                <a:satMod val="350000"/>
-              </a:schemeClr>
-            </a:gs>
-            <a:gs pos="40000">
-              <a:schemeClr val="phClr">
-                <a:tint val="45000"/>
-                <a:shade val="99000"/>
-                <a:satMod val="350000"/>
-              </a:schemeClr>
-            </a:gs>
-            <a:gs pos="100000">
-              <a:schemeClr val="phClr">
-                <a:shade val="20000"/>
-                <a:satMod val="255000"/>
-              </a:schemeClr>
-            </a:gs>
-          </a:gsLst>
-          <a:path path="circle">
-            <a:fillToRect l="50000" t="-80000" r="50000" b="180000"/>
-          </a:path>
-        </a:gradFill>
-        <a:gradFill rotWithShape="1">
-          <a:gsLst>
-            <a:gs pos="0">
-              <a:schemeClr val="phClr">
-                <a:tint val="80000"/>
-                <a:satMod val="300000"/>
-              </a:schemeClr>
-            </a:gs>
-            <a:gs pos="100000">
-              <a:schemeClr val="phClr">
-                <a:shade val="30000"/>
-                <a:satMod val="200000"/>
-              </a:schemeClr>
-            </a:gs>
-          </a:gsLst>
-          <a:path path="circle">
-            <a:fillToRect l="50000" t="50000" r="50000" b="50000"/>
-          </a:path>
-        </a:gradFill>
-      </a:bgFillStyleLst>
-    </a:fmtScheme>
-  </a:themeElements>
-</a:theme>
 </file>
</xml_diff>

<commit_message>
Add images and update reference
</commit_message>
<xml_diff>
--- a/2023263 AI CA1.pptx
+++ b/2023263 AI CA1.pptx
@@ -14558,8 +14558,8 @@
         </p:nvSpPr>
         <p:spPr>
           <a:xfrm>
-            <a:off x="28943300" y="14419262"/>
-            <a:ext cx="12787312" cy="461962"/>
+            <a:off x="28978325" y="16346012"/>
+            <a:ext cx="12787200" cy="446400"/>
           </a:xfrm>
           <a:prstGeom prst="rect">
             <a:avLst/>
@@ -14657,7 +14657,15 @@
               <a:t>Fig. 1 </a:t>
             </a:r>
             <a:r>
-              <a:rPr b="0" i="0" lang="en-US" sz="2400" u="none">
+              <a:rPr i="0" lang="en-US" sz="2400" u="none">
+                <a:solidFill>
+                  <a:schemeClr val="dk1"/>
+                </a:solidFill>
+              </a:rPr>
+              <a:t>Tom Cruise</a:t>
+            </a:r>
+            <a:r>
+              <a:rPr b="1" i="0" lang="en-US" sz="2400" u="none">
                 <a:solidFill>
                   <a:schemeClr val="dk1"/>
                 </a:solidFill>
@@ -14666,7 +14674,23 @@
                 <a:cs typeface="Arial"/>
                 <a:sym typeface="Arial"/>
               </a:rPr>
-              <a:t>Caption size 24pt Arial and exactly 34pt space between lines</a:t>
+              <a:t> </a:t>
+            </a:r>
+            <a:r>
+              <a:rPr i="0" lang="en-US" sz="2400" u="none">
+                <a:solidFill>
+                  <a:schemeClr val="dk1"/>
+                </a:solidFill>
+              </a:rPr>
+              <a:t>Deep</a:t>
+            </a:r>
+            <a:r>
+              <a:rPr lang="en-US" sz="2400">
+                <a:solidFill>
+                  <a:schemeClr val="dk1"/>
+                </a:solidFill>
+              </a:rPr>
+              <a:t>fake Umé (2026)</a:t>
             </a:r>
             <a:endParaRPr/>
           </a:p>
@@ -14732,64 +14756,6 @@
         </p:nvSpPr>
         <p:spPr>
           <a:xfrm>
-            <a:off x="15182500" y="20196375"/>
-            <a:ext cx="12660300" cy="8045400"/>
-          </a:xfrm>
-          <a:prstGeom prst="rect">
-            <a:avLst/>
-          </a:prstGeom>
-          <a:noFill/>
-          <a:ln cap="sq" cmpd="sng" w="12700">
-            <a:solidFill>
-              <a:srgbClr val="006684"/>
-            </a:solidFill>
-            <a:prstDash val="solid"/>
-            <a:round/>
-            <a:headEnd len="sm" w="sm" type="none"/>
-            <a:tailEnd len="sm" w="sm" type="none"/>
-          </a:ln>
-        </p:spPr>
-        <p:txBody>
-          <a:bodyPr anchorCtr="0" anchor="ctr" bIns="45700" lIns="91425" spcFirstLastPara="1" rIns="91425" wrap="square" tIns="45700">
-            <a:noAutofit/>
-          </a:bodyPr>
-          <a:lstStyle/>
-          <a:p>
-            <a:pPr indent="0" lvl="0" marL="0" marR="0" rtl="0" algn="l">
-              <a:lnSpc>
-                <a:spcPct val="100000"/>
-              </a:lnSpc>
-              <a:spcBef>
-                <a:spcPts val="0"/>
-              </a:spcBef>
-              <a:spcAft>
-                <a:spcPts val="0"/>
-              </a:spcAft>
-              <a:buNone/>
-            </a:pPr>
-            <a:r>
-              <a:t/>
-            </a:r>
-            <a:endParaRPr b="0" i="0" sz="2300" u="none">
-              <a:solidFill>
-                <a:schemeClr val="dk1"/>
-              </a:solidFill>
-              <a:latin typeface="Arial"/>
-              <a:ea typeface="Arial"/>
-              <a:cs typeface="Arial"/>
-              <a:sym typeface="Arial"/>
-            </a:endParaRPr>
-          </a:p>
-        </p:txBody>
-      </p:sp>
-      <p:sp>
-        <p:nvSpPr>
-          <p:cNvPr id="104" name="Google Shape;104;p13"/>
-          <p:cNvSpPr txBox="1"/>
-          <p:nvPr/>
-        </p:nvSpPr>
-        <p:spPr>
-          <a:xfrm>
             <a:off x="15165388" y="22617500"/>
             <a:ext cx="517500" cy="446400"/>
           </a:xfrm>
@@ -14836,14 +14802,14 @@
       </p:sp>
       <p:sp>
         <p:nvSpPr>
-          <p:cNvPr id="105" name="Google Shape;105;p13"/>
+          <p:cNvPr id="104" name="Google Shape;104;p13"/>
           <p:cNvSpPr txBox="1"/>
           <p:nvPr/>
         </p:nvSpPr>
         <p:spPr>
           <a:xfrm>
-            <a:off x="28943300" y="6221412"/>
-            <a:ext cx="12787200" cy="3898800"/>
+            <a:off x="29038650" y="14922662"/>
+            <a:ext cx="12787200" cy="4186800"/>
           </a:xfrm>
           <a:prstGeom prst="rect">
             <a:avLst/>
@@ -15016,7 +14982,7 @@
       </p:sp>
       <p:grpSp>
         <p:nvGrpSpPr>
-          <p:cNvPr id="106" name="Google Shape;106;p13"/>
+          <p:cNvPr id="105" name="Google Shape;105;p13"/>
           <p:cNvGrpSpPr/>
           <p:nvPr/>
         </p:nvGrpSpPr>
@@ -15030,7 +14996,7 @@
         </p:grpSpPr>
         <p:sp>
           <p:nvSpPr>
-            <p:cNvPr id="107" name="Google Shape;107;p13"/>
+            <p:cNvPr id="106" name="Google Shape;106;p13"/>
             <p:cNvSpPr txBox="1"/>
             <p:nvPr/>
           </p:nvSpPr>
@@ -15076,7 +15042,7 @@
                     <a:srgbClr val="006684"/>
                   </a:solidFill>
                 </a:rPr>
-                <a:t>Real-world use case of deepfake and its impact</a:t>
+                <a:t>Real-world use case and its impact</a:t>
               </a:r>
               <a:endParaRPr/>
             </a:p>
@@ -15084,7 +15050,7 @@
         </p:sp>
         <p:cxnSp>
           <p:nvCxnSpPr>
-            <p:cNvPr id="108" name="Google Shape;108;p13"/>
+            <p:cNvPr id="107" name="Google Shape;107;p13"/>
             <p:cNvCxnSpPr/>
             <p:nvPr/>
           </p:nvCxnSpPr>
@@ -15111,14 +15077,14 @@
       </p:grpSp>
       <p:sp>
         <p:nvSpPr>
-          <p:cNvPr id="109" name="Google Shape;109;p13"/>
+          <p:cNvPr id="108" name="Google Shape;108;p13"/>
           <p:cNvSpPr txBox="1"/>
           <p:nvPr/>
         </p:nvSpPr>
         <p:spPr>
           <a:xfrm>
-            <a:off x="28917900" y="25650900"/>
-            <a:ext cx="12306300" cy="3648000"/>
+            <a:off x="28917900" y="25640900"/>
+            <a:ext cx="12306300" cy="3628500"/>
           </a:xfrm>
           <a:prstGeom prst="rect">
             <a:avLst/>
@@ -15192,14 +15158,14 @@
               <a:buNone/>
             </a:pPr>
             <a:r>
-              <a:rPr lang="en-US" sz="1500">
+              <a:rPr lang="en-US">
                 <a:solidFill>
                   <a:schemeClr val="dk1"/>
                 </a:solidFill>
               </a:rPr>
               <a:t>Caballar, R.D. and Stryker, C. (2025). What is computer vision? | IBM. [online] Ibm.com. Available at: https://www.ibm.com/think/topics/computer-vision.</a:t>
             </a:r>
-            <a:endParaRPr sz="1500">
+            <a:endParaRPr>
               <a:solidFill>
                 <a:schemeClr val="dk1"/>
               </a:solidFill>
@@ -15224,14 +15190,14 @@
               <a:buNone/>
             </a:pPr>
             <a:r>
-              <a:rPr lang="en-US" sz="1500">
+              <a:rPr lang="en-US">
                 <a:solidFill>
                   <a:schemeClr val="dk1"/>
                 </a:solidFill>
               </a:rPr>
               <a:t>Chen, H. and Magramo, K. (2024). Finance worker pays out $25 million after video call with deepfake ‘chief financial officer’. [online] CNN. Available at: https://edition.cnn.com/2024/02/04/asia/deepfake-cfo-scam-hong-kong-intl-hnk [Accessed 22 Oct. 2026].</a:t>
             </a:r>
-            <a:endParaRPr sz="1500">
+            <a:endParaRPr>
               <a:solidFill>
                 <a:schemeClr val="dk1"/>
               </a:solidFill>
@@ -15256,14 +15222,14 @@
               <a:buNone/>
             </a:pPr>
             <a:r>
-              <a:rPr lang="en-US" sz="1500">
+              <a:rPr lang="en-US">
                 <a:solidFill>
                   <a:schemeClr val="dk1"/>
                 </a:solidFill>
               </a:rPr>
               <a:t>Priyanga, M.G., Kumar Pandey, A., Aathif H, M., Shankar K B, V. and Kumar S, S. (2026). Deepfake shield: An intelligent deepfake detection system. International Scientific Journal of Engineering &amp; Management, 5(4), pp.pp. 1–8. doi:10.55041/ISJEM06433.</a:t>
             </a:r>
-            <a:endParaRPr sz="1500">
+            <a:endParaRPr>
               <a:solidFill>
                 <a:schemeClr val="dk1"/>
               </a:solidFill>
@@ -15288,14 +15254,46 @@
               <a:buNone/>
             </a:pPr>
             <a:r>
-              <a:rPr lang="en-US" sz="1500">
+              <a:rPr lang="en-US">
+                <a:solidFill>
+                  <a:schemeClr val="dk1"/>
+                </a:solidFill>
+              </a:rPr>
+              <a:t>Umé, C. (2026). Chris Umé (@vfxchrisume) on X. [online] X (formerly Twitter). Available at: https://x.com/vfxchrisume [Accessed 22 Oct. 2026].</a:t>
+            </a:r>
+            <a:endParaRPr>
+              <a:solidFill>
+                <a:schemeClr val="dk1"/>
+              </a:solidFill>
+            </a:endParaRPr>
+          </a:p>
+          <a:p>
+            <a:pPr indent="0" lvl="0" marL="0" marR="0" rtl="0" algn="l">
+              <a:lnSpc>
+                <a:spcPct val="146666"/>
+              </a:lnSpc>
+              <a:spcBef>
+                <a:spcPts val="1200"/>
+              </a:spcBef>
+              <a:spcAft>
+                <a:spcPts val="0"/>
+              </a:spcAft>
+              <a:buClr>
+                <a:schemeClr val="dk1"/>
+              </a:buClr>
+              <a:buSzPts val="1500"/>
+              <a:buFont typeface="Arial"/>
+              <a:buNone/>
+            </a:pPr>
+            <a:r>
+              <a:rPr lang="en-US">
                 <a:solidFill>
                   <a:schemeClr val="dk1"/>
                 </a:solidFill>
               </a:rPr>
               <a:t>Verma, Y. (2025). Artificial intelligence-driven robotics: Foundations, architectures, applications, and future directions. International Scientific Journal of Engineering &amp; Management, 4(12), pp.1–6. doi:10.55041/ISJEM05307.</a:t>
             </a:r>
-            <a:endParaRPr sz="1500">
+            <a:endParaRPr>
               <a:solidFill>
                 <a:schemeClr val="dk1"/>
               </a:solidFill>
@@ -15305,13 +15303,13 @@
       </p:sp>
       <p:grpSp>
         <p:nvGrpSpPr>
-          <p:cNvPr id="110" name="Google Shape;110;p13"/>
+          <p:cNvPr id="109" name="Google Shape;109;p13"/>
           <p:cNvGrpSpPr/>
           <p:nvPr/>
         </p:nvGrpSpPr>
         <p:grpSpPr>
           <a:xfrm>
-            <a:off x="28917993" y="4972195"/>
+            <a:off x="29013343" y="13673445"/>
             <a:ext cx="12885817" cy="1108107"/>
             <a:chOff x="14894284" y="5068979"/>
             <a:chExt cx="12887106" cy="1107996"/>
@@ -15319,7 +15317,7 @@
         </p:grpSpPr>
         <p:sp>
           <p:nvSpPr>
-            <p:cNvPr id="111" name="Google Shape;111;p13"/>
+            <p:cNvPr id="110" name="Google Shape;110;p13"/>
             <p:cNvSpPr txBox="1"/>
             <p:nvPr/>
           </p:nvSpPr>
@@ -15377,7 +15375,7 @@
         </p:sp>
         <p:cxnSp>
           <p:nvCxnSpPr>
-            <p:cNvPr id="112" name="Google Shape;112;p13"/>
+            <p:cNvPr id="111" name="Google Shape;111;p13"/>
             <p:cNvCxnSpPr/>
             <p:nvPr/>
           </p:nvCxnSpPr>
@@ -15404,7 +15402,7 @@
       </p:grpSp>
       <p:sp>
         <p:nvSpPr>
-          <p:cNvPr id="113" name="Google Shape;113;p13"/>
+          <p:cNvPr id="112" name="Google Shape;112;p13"/>
           <p:cNvSpPr txBox="1"/>
           <p:nvPr/>
         </p:nvSpPr>
@@ -15462,7 +15460,7 @@
       </p:sp>
       <p:sp>
         <p:nvSpPr>
-          <p:cNvPr id="114" name="Google Shape;114;p13"/>
+          <p:cNvPr id="113" name="Google Shape;113;p13"/>
           <p:cNvSpPr txBox="1"/>
           <p:nvPr/>
         </p:nvSpPr>
@@ -15516,7 +15514,7 @@
       </p:sp>
       <p:sp>
         <p:nvSpPr>
-          <p:cNvPr id="115" name="Google Shape;115;p13"/>
+          <p:cNvPr id="114" name="Google Shape;114;p13"/>
           <p:cNvSpPr txBox="1"/>
           <p:nvPr/>
         </p:nvSpPr>
@@ -15570,7 +15568,7 @@
       </p:sp>
       <p:sp>
         <p:nvSpPr>
-          <p:cNvPr id="116" name="Google Shape;116;p13"/>
+          <p:cNvPr id="115" name="Google Shape;115;p13"/>
           <p:cNvSpPr txBox="1"/>
           <p:nvPr/>
         </p:nvSpPr>
@@ -15624,7 +15622,7 @@
       </p:sp>
       <p:sp>
         <p:nvSpPr>
-          <p:cNvPr id="117" name="Google Shape;117;p13"/>
+          <p:cNvPr id="116" name="Google Shape;116;p13"/>
           <p:cNvSpPr txBox="1"/>
           <p:nvPr/>
         </p:nvSpPr>
@@ -15690,7 +15688,7 @@
       </p:sp>
       <p:pic>
         <p:nvPicPr>
-          <p:cNvPr descr="A blue and black text&#10;&#10;Description automatically generated" id="118" name="Google Shape;118;p13"/>
+          <p:cNvPr descr="A blue and black text&#10;&#10;Description automatically generated" id="117" name="Google Shape;117;p13"/>
           <p:cNvPicPr preferRelativeResize="0"/>
           <p:nvPr/>
         </p:nvPicPr>
@@ -15717,7 +15715,7 @@
       </p:pic>
       <p:sp>
         <p:nvSpPr>
-          <p:cNvPr id="119" name="Google Shape;119;p13"/>
+          <p:cNvPr id="118" name="Google Shape;118;p13"/>
           <p:cNvSpPr txBox="1"/>
           <p:nvPr/>
         </p:nvSpPr>
@@ -15773,6 +15771,150 @@
           </a:p>
         </p:txBody>
       </p:sp>
+      <p:pic>
+        <p:nvPicPr>
+          <p:cNvPr id="119" name="Google Shape;119;p13"/>
+          <p:cNvPicPr preferRelativeResize="0"/>
+          <p:nvPr/>
+        </p:nvPicPr>
+        <p:blipFill>
+          <a:blip r:embed="rId4">
+            <a:alphaModFix/>
+          </a:blip>
+          <a:stretch>
+            <a:fillRect/>
+          </a:stretch>
+        </p:blipFill>
+        <p:spPr>
+          <a:xfrm>
+            <a:off x="15182500" y="20196403"/>
+            <a:ext cx="5105181" cy="7738650"/>
+          </a:xfrm>
+          <a:prstGeom prst="rect">
+            <a:avLst/>
+          </a:prstGeom>
+          <a:noFill/>
+          <a:ln>
+            <a:noFill/>
+          </a:ln>
+        </p:spPr>
+      </p:pic>
+      <p:sp>
+        <p:nvSpPr>
+          <p:cNvPr id="120" name="Google Shape;120;p13"/>
+          <p:cNvSpPr/>
+          <p:nvPr/>
+        </p:nvSpPr>
+        <p:spPr>
+          <a:xfrm>
+            <a:off x="20891663" y="23623663"/>
+            <a:ext cx="1001100" cy="808200"/>
+          </a:xfrm>
+          <a:prstGeom prst="rightArrow">
+            <a:avLst>
+              <a:gd fmla="val 50000" name="adj1"/>
+              <a:gd fmla="val 50000" name="adj2"/>
+            </a:avLst>
+          </a:prstGeom>
+          <a:solidFill>
+            <a:schemeClr val="lt1"/>
+          </a:solidFill>
+          <a:ln cap="flat" cmpd="sng" w="9525">
+            <a:solidFill>
+              <a:srgbClr val="222222"/>
+            </a:solidFill>
+            <a:prstDash val="solid"/>
+            <a:round/>
+            <a:headEnd len="sm" w="sm" type="none"/>
+            <a:tailEnd len="sm" w="sm" type="none"/>
+          </a:ln>
+        </p:spPr>
+        <p:txBody>
+          <a:bodyPr anchorCtr="0" anchor="ctr" bIns="91425" lIns="91425" spcFirstLastPara="1" rIns="91425" wrap="square" tIns="91425">
+            <a:noAutofit/>
+          </a:bodyPr>
+          <a:lstStyle/>
+          <a:p>
+            <a:pPr indent="0" lvl="0" marL="0" rtl="0" algn="ctr">
+              <a:spcBef>
+                <a:spcPts val="0"/>
+              </a:spcBef>
+              <a:spcAft>
+                <a:spcPts val="0"/>
+              </a:spcAft>
+              <a:buNone/>
+            </a:pPr>
+            <a:r>
+              <a:t/>
+            </a:r>
+            <a:endParaRPr>
+              <a:solidFill>
+                <a:srgbClr val="006CFF"/>
+              </a:solidFill>
+              <a:latin typeface="Times New Roman"/>
+              <a:ea typeface="Times New Roman"/>
+              <a:cs typeface="Times New Roman"/>
+              <a:sym typeface="Times New Roman"/>
+            </a:endParaRPr>
+          </a:p>
+        </p:txBody>
+      </p:sp>
+      <p:pic>
+        <p:nvPicPr>
+          <p:cNvPr id="121" name="Google Shape;121;p13"/>
+          <p:cNvPicPr preferRelativeResize="0"/>
+          <p:nvPr/>
+        </p:nvPicPr>
+        <p:blipFill>
+          <a:blip r:embed="rId5">
+            <a:alphaModFix/>
+          </a:blip>
+          <a:stretch>
+            <a:fillRect/>
+          </a:stretch>
+        </p:blipFill>
+        <p:spPr>
+          <a:xfrm>
+            <a:off x="32518463" y="5116101"/>
+            <a:ext cx="5105175" cy="7680937"/>
+          </a:xfrm>
+          <a:prstGeom prst="rect">
+            <a:avLst/>
+          </a:prstGeom>
+          <a:noFill/>
+          <a:ln>
+            <a:noFill/>
+          </a:ln>
+        </p:spPr>
+      </p:pic>
+      <p:pic>
+        <p:nvPicPr>
+          <p:cNvPr id="122" name="Google Shape;122;p13"/>
+          <p:cNvPicPr preferRelativeResize="0"/>
+          <p:nvPr/>
+        </p:nvPicPr>
+        <p:blipFill>
+          <a:blip r:embed="rId6">
+            <a:alphaModFix/>
+          </a:blip>
+          <a:stretch>
+            <a:fillRect/>
+          </a:stretch>
+        </p:blipFill>
+        <p:spPr>
+          <a:xfrm>
+            <a:off x="22496775" y="20158450"/>
+            <a:ext cx="5262254" cy="7738650"/>
+          </a:xfrm>
+          <a:prstGeom prst="rect">
+            <a:avLst/>
+          </a:prstGeom>
+          <a:noFill/>
+          <a:ln>
+            <a:noFill/>
+          </a:ln>
+        </p:spPr>
+      </p:pic>
     </p:spTree>
   </p:cSld>
   <p:clrMapOvr>

</xml_diff>

<commit_message>
Add url to github repository
</commit_message>
<xml_diff>
--- a/2023263 AI CA1.pptx
+++ b/2023263 AI CA1.pptx
@@ -14269,9 +14269,9 @@
         <p:grpSpPr>
           <a:xfrm>
             <a:off x="920750" y="4964112"/>
-            <a:ext cx="12885737" cy="1000571"/>
+            <a:ext cx="12885723" cy="1000571"/>
             <a:chOff x="967545" y="5020846"/>
-            <a:chExt cx="12885433" cy="1000500"/>
+            <a:chExt cx="12885419" cy="1000500"/>
           </a:xfrm>
         </p:grpSpPr>
         <p:sp>
@@ -14335,9 +14335,9 @@
             <p:nvPr/>
           </p:nvCxnSpPr>
           <p:spPr>
-            <a:xfrm flipH="1" rot="10800000">
-              <a:off x="1107464" y="5164436"/>
-              <a:ext cx="12745514" cy="1"/>
+            <a:xfrm>
+              <a:off x="1107464" y="5164437"/>
+              <a:ext cx="12745500" cy="0"/>
             </a:xfrm>
             <a:prstGeom prst="straightConnector1">
               <a:avLst/>
@@ -16099,6 +16099,97 @@
               <a:t>fake final step. Credits to Umé (2026)</a:t>
             </a:r>
             <a:endParaRPr/>
+          </a:p>
+        </p:txBody>
+      </p:sp>
+      <p:sp>
+        <p:nvSpPr>
+          <p:cNvPr id="126" name="Google Shape;126;p13"/>
+          <p:cNvSpPr txBox="1"/>
+          <p:nvPr/>
+        </p:nvSpPr>
+        <p:spPr>
+          <a:xfrm>
+            <a:off x="28923450" y="23387077"/>
+            <a:ext cx="12787200" cy="1416000"/>
+          </a:xfrm>
+          <a:prstGeom prst="rect">
+            <a:avLst/>
+          </a:prstGeom>
+          <a:noFill/>
+          <a:ln>
+            <a:noFill/>
+          </a:ln>
+        </p:spPr>
+        <p:txBody>
+          <a:bodyPr anchorCtr="0" anchor="t" bIns="45700" lIns="91425" spcFirstLastPara="1" rIns="91425" wrap="square" tIns="45700">
+            <a:spAutoFit/>
+          </a:bodyPr>
+          <a:lstStyle/>
+          <a:p>
+            <a:pPr indent="0" lvl="0" marL="0" marR="0" rtl="0" algn="l">
+              <a:lnSpc>
+                <a:spcPct val="138888"/>
+              </a:lnSpc>
+              <a:spcBef>
+                <a:spcPts val="1200"/>
+              </a:spcBef>
+              <a:spcAft>
+                <a:spcPts val="0"/>
+              </a:spcAft>
+              <a:buNone/>
+            </a:pPr>
+            <a:r>
+              <a:rPr b="1" lang="en-US" sz="3600">
+                <a:solidFill>
+                  <a:schemeClr val="dk1"/>
+                </a:solidFill>
+                <a:latin typeface="Helvetica Neue"/>
+                <a:ea typeface="Helvetica Neue"/>
+                <a:cs typeface="Helvetica Neue"/>
+                <a:sym typeface="Helvetica Neue"/>
+              </a:rPr>
+              <a:t>Github</a:t>
+            </a:r>
+            <a:r>
+              <a:rPr lang="en-US" sz="3600">
+                <a:solidFill>
+                  <a:schemeClr val="dk1"/>
+                </a:solidFill>
+                <a:latin typeface="Helvetica Neue"/>
+                <a:ea typeface="Helvetica Neue"/>
+                <a:cs typeface="Helvetica Neue"/>
+                <a:sym typeface="Helvetica Neue"/>
+              </a:rPr>
+              <a:t>: https://github.com/BrenoValle0/AI_CA1_2023263</a:t>
+            </a:r>
+            <a:endParaRPr/>
+          </a:p>
+          <a:p>
+            <a:pPr indent="0" lvl="0" marL="0" marR="0" rtl="0" algn="l">
+              <a:lnSpc>
+                <a:spcPct val="100000"/>
+              </a:lnSpc>
+              <a:spcBef>
+                <a:spcPts val="0"/>
+              </a:spcBef>
+              <a:spcAft>
+                <a:spcPts val="0"/>
+              </a:spcAft>
+              <a:buNone/>
+            </a:pPr>
+            <a:r>
+              <a:t/>
+            </a:r>
+            <a:endParaRPr b="0" i="0" sz="3600" u="none">
+              <a:solidFill>
+                <a:schemeClr val="dk1"/>
+              </a:solidFill>
+              <a:latin typeface="Arial"/>
+              <a:ea typeface="Arial"/>
+              <a:cs typeface="Arial"/>
+              <a:sym typeface="Arial"/>
+            </a:endParaRPr>
           </a:p>
         </p:txBody>
       </p:sp>

</xml_diff>